<commit_message>
Fix Smart Enter not working in free-format RPG when enableRPGSmartEnter is fixedAndFree or *ALL
</commit_message>
<xml_diff>
--- a/CLPROMPTER_PRESENTATION.pptx
+++ b/CLPROMPTER_PRESENTATION.pptx
@@ -23,7 +23,7 @@
     <p:sldId id="271" r:id="rId17"/>
     <p:sldId id="272" r:id="rId18"/>
   </p:sldIdLst>
-  <p:sldSz cx="12192000" cy="6858000"/>
+  <p:sldSz cx="12191695" cy="6858000"/>
   <p:notesSz cx="6858000" cy="9144000"/>
   <p:defaultTextStyle>
     <a:defPPr>
@@ -170,6 +170,7 @@
               <a:rPr lang="en-US" dirty="0"/>
               <a:t>Click to edit Master title style</a:t>
             </a:r>
+            <a:endParaRPr lang="en-US" dirty="0"/>
           </a:p>
         </p:txBody>
       </p:sp>
@@ -289,6 +290,7 @@
               <a:rPr lang="en-US" dirty="0"/>
               <a:t>Click to edit Master subtitle style</a:t>
             </a:r>
+            <a:endParaRPr lang="en-US" dirty="0"/>
           </a:p>
         </p:txBody>
       </p:sp>
@@ -310,7 +312,7 @@
             <a:fld id="{B61BEF0D-F0BB-DE4B-95CE-6DB70DBA9567}" type="datetimeFigureOut">
               <a:rPr lang="en-US" dirty="0"/>
               <a:pPr/>
-              <a:t>4/2/26</a:t>
+              <a:t>1/1/2000</a:t>
             </a:fld>
             <a:endParaRPr lang="en-US" dirty="0"/>
           </a:p>
@@ -338,7 +340,8 @@
       <p:sp>
         <p:nvSpPr>
           <p:cNvPr id="7" name="Freeform 6"/>
-          <p:cNvSpPr/>
+          <p:cNvSpPr>
+          </p:cNvSpPr>
           <p:nvPr/>
         </p:nvSpPr>
         <p:spPr bwMode="auto">
@@ -347,10 +350,6 @@
             <a:ext cx="1744652" cy="778589"/>
           </a:xfrm>
           <a:custGeom>
-            <a:avLst/>
-            <a:gdLst/>
-            <a:ahLst/>
-            <a:cxnLst/>
             <a:rect l="0" t="0" r="r" b="b"/>
             <a:pathLst>
               <a:path w="372" h="166">
@@ -438,7 +437,7 @@
           <a:lstStyle/>
           <a:p>
             <a:fld id="{D57F1E4F-1CFF-5643-939E-217C01CDF565}" type="slidenum">
-              <a:rPr lang="en-US" dirty="0"/>
+              <a:rPr dirty="0" lang="en-US"/>
               <a:pPr/>
               <a:t>‹#›</a:t>
             </a:fld>
@@ -501,6 +500,7 @@
               <a:rPr lang="en-US" dirty="0"/>
               <a:t>Click to edit Master title style</a:t>
             </a:r>
+            <a:endParaRPr lang="en-US" dirty="0"/>
           </a:p>
         </p:txBody>
       </p:sp>
@@ -644,7 +644,7 @@
             <a:fld id="{B61BEF0D-F0BB-DE4B-95CE-6DB70DBA9567}" type="datetimeFigureOut">
               <a:rPr lang="en-US" dirty="0"/>
               <a:pPr/>
-              <a:t>4/2/26</a:t>
+              <a:t>1/1/2000</a:t>
             </a:fld>
             <a:endParaRPr lang="en-US" dirty="0"/>
           </a:p>
@@ -672,7 +672,8 @@
       <p:sp>
         <p:nvSpPr>
           <p:cNvPr id="9" name="Freeform 11"/>
-          <p:cNvSpPr/>
+          <p:cNvSpPr>
+          </p:cNvSpPr>
           <p:nvPr/>
         </p:nvSpPr>
         <p:spPr bwMode="auto">
@@ -681,10 +682,6 @@
             <a:ext cx="1588527" cy="507297"/>
           </a:xfrm>
           <a:custGeom>
-            <a:avLst/>
-            <a:gdLst/>
-            <a:ahLst/>
-            <a:cxnLst/>
             <a:rect l="l" t="t" r="r" b="b"/>
             <a:pathLst>
               <a:path w="9248" h="10000">
@@ -772,7 +769,7 @@
           <a:lstStyle/>
           <a:p>
             <a:fld id="{D57F1E4F-1CFF-5643-939E-217C01CDF565}" type="slidenum">
-              <a:rPr lang="en-US" dirty="0"/>
+              <a:rPr dirty="0" lang="en-US"/>
               <a:pPr/>
               <a:t>‹#›</a:t>
             </a:fld>
@@ -835,6 +832,7 @@
               <a:rPr lang="en-US" dirty="0"/>
               <a:t>Click to edit Master title style</a:t>
             </a:r>
+            <a:endParaRPr lang="en-US" dirty="0"/>
           </a:p>
         </p:txBody>
       </p:sp>
@@ -1041,7 +1039,7 @@
             <a:fld id="{B61BEF0D-F0BB-DE4B-95CE-6DB70DBA9567}" type="datetimeFigureOut">
               <a:rPr lang="en-US" dirty="0"/>
               <a:pPr/>
-              <a:t>4/2/26</a:t>
+              <a:t>1/1/2000</a:t>
             </a:fld>
             <a:endParaRPr lang="en-US" dirty="0"/>
           </a:p>
@@ -1069,7 +1067,8 @@
       <p:sp>
         <p:nvSpPr>
           <p:cNvPr id="11" name="Freeform 11"/>
-          <p:cNvSpPr/>
+          <p:cNvSpPr>
+          </p:cNvSpPr>
           <p:nvPr/>
         </p:nvSpPr>
         <p:spPr bwMode="auto">
@@ -1078,10 +1077,6 @@
             <a:ext cx="1588527" cy="507297"/>
           </a:xfrm>
           <a:custGeom>
-            <a:avLst/>
-            <a:gdLst/>
-            <a:ahLst/>
-            <a:cxnLst/>
             <a:rect l="l" t="t" r="r" b="b"/>
             <a:pathLst>
               <a:path w="9248" h="10000">
@@ -1169,7 +1164,7 @@
           <a:lstStyle/>
           <a:p>
             <a:fld id="{D57F1E4F-1CFF-5643-939E-217C01CDF565}" type="slidenum">
-              <a:rPr lang="en-US" dirty="0"/>
+              <a:rPr dirty="0" lang="en-US"/>
               <a:pPr/>
               <a:t>‹#›</a:t>
             </a:fld>
@@ -1189,7 +1184,6 @@
             <a:ext cx="609600" cy="584776"/>
           </a:xfrm>
           <a:prstGeom prst="rect">
-            <a:avLst/>
           </a:prstGeom>
         </p:spPr>
         <p:txBody>
@@ -1212,6 +1206,16 @@
               </a:rPr>
               <a:t>“</a:t>
             </a:r>
+            <a:endParaRPr lang="en-US" sz="8000" baseline="0" dirty="0">
+              <a:ln w="3175" cmpd="sng">
+                <a:noFill/>
+              </a:ln>
+              <a:solidFill>
+                <a:schemeClr val="accent1"/>
+              </a:solidFill>
+              <a:effectLst/>
+              <a:latin typeface="Arial"/>
+            </a:endParaRPr>
           </a:p>
         </p:txBody>
       </p:sp>
@@ -1227,7 +1231,6 @@
             <a:ext cx="609600" cy="584776"/>
           </a:xfrm>
           <a:prstGeom prst="rect">
-            <a:avLst/>
           </a:prstGeom>
         </p:spPr>
         <p:txBody>
@@ -1250,6 +1253,16 @@
               </a:rPr>
               <a:t>”</a:t>
             </a:r>
+            <a:endParaRPr lang="en-US" sz="8000" baseline="0" dirty="0">
+              <a:ln w="3175" cmpd="sng">
+                <a:noFill/>
+              </a:ln>
+              <a:solidFill>
+                <a:schemeClr val="accent1"/>
+              </a:solidFill>
+              <a:effectLst/>
+              <a:latin typeface="Arial"/>
+            </a:endParaRPr>
           </a:p>
         </p:txBody>
       </p:sp>
@@ -1308,6 +1321,7 @@
               <a:rPr lang="en-US" dirty="0"/>
               <a:t>Click to edit Master title style</a:t>
             </a:r>
+            <a:endParaRPr lang="en-US" dirty="0"/>
           </a:p>
         </p:txBody>
       </p:sp>
@@ -1373,7 +1387,7 @@
             <a:fld id="{B61BEF0D-F0BB-DE4B-95CE-6DB70DBA9567}" type="datetimeFigureOut">
               <a:rPr lang="en-US" dirty="0"/>
               <a:pPr/>
-              <a:t>4/2/26</a:t>
+              <a:t>1/1/2000</a:t>
             </a:fld>
             <a:endParaRPr lang="en-US" dirty="0"/>
           </a:p>
@@ -1401,7 +1415,8 @@
       <p:sp>
         <p:nvSpPr>
           <p:cNvPr id="9" name="Freeform 11"/>
-          <p:cNvSpPr/>
+          <p:cNvSpPr>
+          </p:cNvSpPr>
           <p:nvPr/>
         </p:nvSpPr>
         <p:spPr bwMode="auto">
@@ -1410,10 +1425,6 @@
             <a:ext cx="1588527" cy="507297"/>
           </a:xfrm>
           <a:custGeom>
-            <a:avLst/>
-            <a:gdLst/>
-            <a:ahLst/>
-            <a:cxnLst/>
             <a:rect l="l" t="t" r="r" b="b"/>
             <a:pathLst>
               <a:path w="9248" h="10000">
@@ -1501,7 +1512,7 @@
           <a:lstStyle/>
           <a:p>
             <a:fld id="{D57F1E4F-1CFF-5643-939E-217C01CDF565}" type="slidenum">
-              <a:rPr lang="en-US" dirty="0"/>
+              <a:rPr dirty="0" lang="en-US"/>
               <a:pPr/>
               <a:t>‹#›</a:t>
             </a:fld>
@@ -1564,6 +1575,7 @@
               <a:rPr lang="en-US" dirty="0"/>
               <a:t>Click to edit Master title style</a:t>
             </a:r>
+            <a:endParaRPr lang="en-US" dirty="0"/>
           </a:p>
         </p:txBody>
       </p:sp>
@@ -1689,7 +1701,7 @@
             <a:fld id="{B61BEF0D-F0BB-DE4B-95CE-6DB70DBA9567}" type="datetimeFigureOut">
               <a:rPr lang="en-US" dirty="0"/>
               <a:pPr/>
-              <a:t>4/2/26</a:t>
+              <a:t>1/1/2000</a:t>
             </a:fld>
             <a:endParaRPr lang="en-US" dirty="0"/>
           </a:p>
@@ -1717,7 +1729,8 @@
       <p:sp>
         <p:nvSpPr>
           <p:cNvPr id="11" name="Freeform 11"/>
-          <p:cNvSpPr/>
+          <p:cNvSpPr>
+          </p:cNvSpPr>
           <p:nvPr/>
         </p:nvSpPr>
         <p:spPr bwMode="auto">
@@ -1726,10 +1739,6 @@
             <a:ext cx="1588527" cy="507297"/>
           </a:xfrm>
           <a:custGeom>
-            <a:avLst/>
-            <a:gdLst/>
-            <a:ahLst/>
-            <a:cxnLst/>
             <a:rect l="l" t="t" r="r" b="b"/>
             <a:pathLst>
               <a:path w="9248" h="10000">
@@ -1817,7 +1826,7 @@
           <a:lstStyle/>
           <a:p>
             <a:fld id="{D57F1E4F-1CFF-5643-939E-217C01CDF565}" type="slidenum">
-              <a:rPr lang="en-US" dirty="0"/>
+              <a:rPr dirty="0" lang="en-US"/>
               <a:pPr/>
               <a:t>‹#›</a:t>
             </a:fld>
@@ -1837,7 +1846,6 @@
             <a:ext cx="609600" cy="584776"/>
           </a:xfrm>
           <a:prstGeom prst="rect">
-            <a:avLst/>
           </a:prstGeom>
         </p:spPr>
         <p:txBody>
@@ -1860,6 +1868,16 @@
               </a:rPr>
               <a:t>“</a:t>
             </a:r>
+            <a:endParaRPr lang="en-US" sz="8000" baseline="0" dirty="0">
+              <a:ln w="3175" cmpd="sng">
+                <a:noFill/>
+              </a:ln>
+              <a:solidFill>
+                <a:schemeClr val="accent1"/>
+              </a:solidFill>
+              <a:effectLst/>
+              <a:latin typeface="Arial"/>
+            </a:endParaRPr>
           </a:p>
         </p:txBody>
       </p:sp>
@@ -1875,7 +1893,6 @@
             <a:ext cx="609600" cy="584776"/>
           </a:xfrm>
           <a:prstGeom prst="rect">
-            <a:avLst/>
           </a:prstGeom>
         </p:spPr>
         <p:txBody>
@@ -1898,6 +1915,16 @@
               </a:rPr>
               <a:t>”</a:t>
             </a:r>
+            <a:endParaRPr lang="en-US" sz="8000" baseline="0" dirty="0">
+              <a:ln w="3175" cmpd="sng">
+                <a:noFill/>
+              </a:ln>
+              <a:solidFill>
+                <a:schemeClr val="accent1"/>
+              </a:solidFill>
+              <a:effectLst/>
+              <a:latin typeface="Arial"/>
+            </a:endParaRPr>
           </a:p>
         </p:txBody>
       </p:sp>
@@ -1956,6 +1983,7 @@
               <a:rPr lang="en-US" dirty="0"/>
               <a:t>Click to edit Master title style</a:t>
             </a:r>
+            <a:endParaRPr lang="en-US" dirty="0"/>
           </a:p>
         </p:txBody>
       </p:sp>
@@ -2081,7 +2109,7 @@
             <a:fld id="{B61BEF0D-F0BB-DE4B-95CE-6DB70DBA9567}" type="datetimeFigureOut">
               <a:rPr lang="en-US" dirty="0"/>
               <a:pPr/>
-              <a:t>4/2/26</a:t>
+              <a:t>1/1/2000</a:t>
             </a:fld>
             <a:endParaRPr lang="en-US" dirty="0"/>
           </a:p>
@@ -2109,7 +2137,8 @@
       <p:sp>
         <p:nvSpPr>
           <p:cNvPr id="9" name="Freeform 11"/>
-          <p:cNvSpPr/>
+          <p:cNvSpPr>
+          </p:cNvSpPr>
           <p:nvPr/>
         </p:nvSpPr>
         <p:spPr bwMode="auto">
@@ -2118,10 +2147,6 @@
             <a:ext cx="1588527" cy="507297"/>
           </a:xfrm>
           <a:custGeom>
-            <a:avLst/>
-            <a:gdLst/>
-            <a:ahLst/>
-            <a:cxnLst/>
             <a:rect l="l" t="t" r="r" b="b"/>
             <a:pathLst>
               <a:path w="9248" h="10000">
@@ -2209,7 +2234,7 @@
           <a:lstStyle/>
           <a:p>
             <a:fld id="{D57F1E4F-1CFF-5643-939E-217C01CDF565}" type="slidenum">
-              <a:rPr lang="en-US" dirty="0"/>
+              <a:rPr dirty="0" lang="en-US"/>
               <a:pPr/>
               <a:t>‹#›</a:t>
             </a:fld>
@@ -2261,6 +2286,7 @@
               <a:rPr lang="en-US" dirty="0"/>
               <a:t>Click to edit Master title style</a:t>
             </a:r>
+            <a:endParaRPr lang="en-US" dirty="0"/>
           </a:p>
         </p:txBody>
       </p:sp>
@@ -2312,6 +2338,7 @@
               <a:rPr lang="en-US" dirty="0"/>
               <a:t>Fifth level</a:t>
             </a:r>
+            <a:endParaRPr lang="en-US" dirty="0"/>
           </a:p>
         </p:txBody>
       </p:sp>
@@ -2333,7 +2360,7 @@
             <a:fld id="{B61BEF0D-F0BB-DE4B-95CE-6DB70DBA9567}" type="datetimeFigureOut">
               <a:rPr lang="en-US" dirty="0"/>
               <a:pPr/>
-              <a:t>4/2/26</a:t>
+              <a:t>1/1/2000</a:t>
             </a:fld>
             <a:endParaRPr lang="en-US" dirty="0"/>
           </a:p>
@@ -2361,7 +2388,8 @@
       <p:sp>
         <p:nvSpPr>
           <p:cNvPr id="8" name="Freeform 11"/>
-          <p:cNvSpPr/>
+          <p:cNvSpPr>
+          </p:cNvSpPr>
           <p:nvPr/>
         </p:nvSpPr>
         <p:spPr bwMode="auto">
@@ -2370,10 +2398,6 @@
             <a:ext cx="1588527" cy="507297"/>
           </a:xfrm>
           <a:custGeom>
-            <a:avLst/>
-            <a:gdLst/>
-            <a:ahLst/>
-            <a:cxnLst/>
             <a:rect l="l" t="t" r="r" b="b"/>
             <a:pathLst>
               <a:path w="9248" h="10000">
@@ -2456,7 +2480,7 @@
           <a:lstStyle/>
           <a:p>
             <a:fld id="{D57F1E4F-1CFF-5643-939E-217C01CDF565}" type="slidenum">
-              <a:rPr lang="en-US" dirty="0"/>
+              <a:rPr dirty="0" lang="en-US"/>
               <a:pPr/>
               <a:t>‹#›</a:t>
             </a:fld>
@@ -2513,6 +2537,7 @@
               <a:rPr lang="en-US" dirty="0"/>
               <a:t>Click to edit Master title style</a:t>
             </a:r>
+            <a:endParaRPr lang="en-US" dirty="0"/>
           </a:p>
         </p:txBody>
       </p:sp>
@@ -2569,6 +2594,7 @@
               <a:rPr lang="en-US" dirty="0"/>
               <a:t>Fifth level</a:t>
             </a:r>
+            <a:endParaRPr lang="en-US" dirty="0"/>
           </a:p>
         </p:txBody>
       </p:sp>
@@ -2590,7 +2616,7 @@
             <a:fld id="{B61BEF0D-F0BB-DE4B-95CE-6DB70DBA9567}" type="datetimeFigureOut">
               <a:rPr lang="en-US" dirty="0"/>
               <a:pPr/>
-              <a:t>4/2/26</a:t>
+              <a:t>1/1/2000</a:t>
             </a:fld>
             <a:endParaRPr lang="en-US" dirty="0"/>
           </a:p>
@@ -2618,7 +2644,8 @@
       <p:sp>
         <p:nvSpPr>
           <p:cNvPr id="8" name="Freeform 11"/>
-          <p:cNvSpPr/>
+          <p:cNvSpPr>
+          </p:cNvSpPr>
           <p:nvPr/>
         </p:nvSpPr>
         <p:spPr bwMode="auto">
@@ -2627,10 +2654,6 @@
             <a:ext cx="1588527" cy="507297"/>
           </a:xfrm>
           <a:custGeom>
-            <a:avLst/>
-            <a:gdLst/>
-            <a:ahLst/>
-            <a:cxnLst/>
             <a:rect l="l" t="t" r="r" b="b"/>
             <a:pathLst>
               <a:path w="9248" h="10000">
@@ -2713,7 +2736,7 @@
           <a:lstStyle/>
           <a:p>
             <a:fld id="{D57F1E4F-1CFF-5643-939E-217C01CDF565}" type="slidenum">
-              <a:rPr lang="en-US" dirty="0"/>
+              <a:rPr dirty="0" lang="en-US"/>
               <a:pPr/>
               <a:t>‹#›</a:t>
             </a:fld>
@@ -2770,6 +2793,7 @@
               <a:rPr lang="en-US" dirty="0"/>
               <a:t>Click to edit Master title style</a:t>
             </a:r>
+            <a:endParaRPr lang="en-US" dirty="0"/>
           </a:p>
         </p:txBody>
       </p:sp>
@@ -2826,6 +2850,7 @@
               <a:rPr lang="en-US" dirty="0"/>
               <a:t>Fifth level</a:t>
             </a:r>
+            <a:endParaRPr lang="en-US" dirty="0"/>
           </a:p>
         </p:txBody>
       </p:sp>
@@ -2847,7 +2872,7 @@
             <a:fld id="{B61BEF0D-F0BB-DE4B-95CE-6DB70DBA9567}" type="datetimeFigureOut">
               <a:rPr lang="en-US" dirty="0"/>
               <a:pPr/>
-              <a:t>4/2/26</a:t>
+              <a:t>1/1/2000</a:t>
             </a:fld>
             <a:endParaRPr lang="en-US" dirty="0"/>
           </a:p>
@@ -2875,7 +2900,8 @@
       <p:sp>
         <p:nvSpPr>
           <p:cNvPr id="8" name="Freeform 11"/>
-          <p:cNvSpPr/>
+          <p:cNvSpPr>
+          </p:cNvSpPr>
           <p:nvPr/>
         </p:nvSpPr>
         <p:spPr bwMode="auto">
@@ -2884,10 +2910,6 @@
             <a:ext cx="1588527" cy="507297"/>
           </a:xfrm>
           <a:custGeom>
-            <a:avLst/>
-            <a:gdLst/>
-            <a:ahLst/>
-            <a:cxnLst/>
             <a:rect l="l" t="t" r="r" b="b"/>
             <a:pathLst>
               <a:path w="9248" h="10000">
@@ -2953,13 +2975,6 @@
             <a:noFill/>
           </a:ln>
         </p:spPr>
-        <p:txBody>
-          <a:bodyPr/>
-          <a:lstStyle/>
-          <a:p>
-            <a:endParaRPr lang="en-US"/>
-          </a:p>
-        </p:txBody>
       </p:sp>
       <p:sp>
         <p:nvSpPr>
@@ -2977,7 +2992,7 @@
           <a:lstStyle/>
           <a:p>
             <a:fld id="{D57F1E4F-1CFF-5643-939E-217C01CDF565}" type="slidenum">
-              <a:rPr lang="en-US" dirty="0"/>
+              <a:rPr dirty="0" lang="en-US"/>
               <a:pPr/>
               <a:t>‹#›</a:t>
             </a:fld>
@@ -3038,6 +3053,7 @@
               <a:rPr lang="en-US" dirty="0"/>
               <a:t>Click to edit Master title style</a:t>
             </a:r>
+            <a:endParaRPr lang="en-US" dirty="0"/>
           </a:p>
         </p:txBody>
       </p:sp>
@@ -3179,7 +3195,7 @@
             <a:fld id="{B61BEF0D-F0BB-DE4B-95CE-6DB70DBA9567}" type="datetimeFigureOut">
               <a:rPr lang="en-US" dirty="0"/>
               <a:pPr/>
-              <a:t>4/2/26</a:t>
+              <a:t>1/1/2000</a:t>
             </a:fld>
             <a:endParaRPr lang="en-US" dirty="0"/>
           </a:p>
@@ -3207,7 +3223,8 @@
       <p:sp>
         <p:nvSpPr>
           <p:cNvPr id="9" name="Freeform 11"/>
-          <p:cNvSpPr/>
+          <p:cNvSpPr>
+          </p:cNvSpPr>
           <p:nvPr/>
         </p:nvSpPr>
         <p:spPr bwMode="auto">
@@ -3216,10 +3233,6 @@
             <a:ext cx="1588527" cy="507297"/>
           </a:xfrm>
           <a:custGeom>
-            <a:avLst/>
-            <a:gdLst/>
-            <a:ahLst/>
-            <a:cxnLst/>
             <a:rect l="l" t="t" r="r" b="b"/>
             <a:pathLst>
               <a:path w="9248" h="10000">
@@ -3307,7 +3320,7 @@
           <a:lstStyle/>
           <a:p>
             <a:fld id="{D57F1E4F-1CFF-5643-939E-217C01CDF565}" type="slidenum">
-              <a:rPr lang="en-US" dirty="0"/>
+              <a:rPr dirty="0" lang="en-US"/>
               <a:pPr/>
               <a:t>‹#›</a:t>
             </a:fld>
@@ -3359,6 +3372,7 @@
               <a:rPr lang="en-US" dirty="0"/>
               <a:t>Click to edit Master title style</a:t>
             </a:r>
+            <a:endParaRPr lang="en-US" dirty="0"/>
           </a:p>
         </p:txBody>
       </p:sp>
@@ -3417,6 +3431,7 @@
               <a:rPr lang="en-US" dirty="0"/>
               <a:t>Fifth level</a:t>
             </a:r>
+            <a:endParaRPr lang="en-US" dirty="0"/>
           </a:p>
         </p:txBody>
       </p:sp>
@@ -3475,6 +3490,7 @@
               <a:rPr lang="en-US" dirty="0"/>
               <a:t>Fifth level</a:t>
             </a:r>
+            <a:endParaRPr lang="en-US" dirty="0"/>
           </a:p>
         </p:txBody>
       </p:sp>
@@ -3496,7 +3512,7 @@
             <a:fld id="{B61BEF0D-F0BB-DE4B-95CE-6DB70DBA9567}" type="datetimeFigureOut">
               <a:rPr lang="en-US" dirty="0"/>
               <a:pPr/>
-              <a:t>4/2/26</a:t>
+              <a:t>1/1/2000</a:t>
             </a:fld>
             <a:endParaRPr lang="en-US" dirty="0"/>
           </a:p>
@@ -3524,7 +3540,8 @@
       <p:sp>
         <p:nvSpPr>
           <p:cNvPr id="10" name="Freeform 11"/>
-          <p:cNvSpPr/>
+          <p:cNvSpPr>
+          </p:cNvSpPr>
           <p:nvPr/>
         </p:nvSpPr>
         <p:spPr bwMode="auto">
@@ -3533,10 +3550,6 @@
             <a:ext cx="1588527" cy="507297"/>
           </a:xfrm>
           <a:custGeom>
-            <a:avLst/>
-            <a:gdLst/>
-            <a:ahLst/>
-            <a:cxnLst/>
             <a:rect l="l" t="t" r="r" b="b"/>
             <a:pathLst>
               <a:path w="9248" h="10000">
@@ -3624,7 +3637,7 @@
           <a:lstStyle/>
           <a:p>
             <a:fld id="{D57F1E4F-1CFF-5643-939E-217C01CDF565}" type="slidenum">
-              <a:rPr lang="en-US" dirty="0"/>
+              <a:rPr dirty="0" lang="en-US"/>
               <a:pPr/>
               <a:t>‹#›</a:t>
             </a:fld>
@@ -3676,6 +3689,7 @@
               <a:rPr lang="en-US" dirty="0"/>
               <a:t>Click to edit Master title style</a:t>
             </a:r>
+            <a:endParaRPr lang="en-US" dirty="0"/>
           </a:p>
         </p:txBody>
       </p:sp>
@@ -3801,6 +3815,7 @@
               <a:rPr lang="en-US" dirty="0"/>
               <a:t>Fifth level</a:t>
             </a:r>
+            <a:endParaRPr lang="en-US" dirty="0"/>
           </a:p>
         </p:txBody>
       </p:sp>
@@ -3926,6 +3941,7 @@
               <a:rPr lang="en-US" dirty="0"/>
               <a:t>Fifth level</a:t>
             </a:r>
+            <a:endParaRPr lang="en-US" dirty="0"/>
           </a:p>
         </p:txBody>
       </p:sp>
@@ -3947,7 +3963,7 @@
             <a:fld id="{B61BEF0D-F0BB-DE4B-95CE-6DB70DBA9567}" type="datetimeFigureOut">
               <a:rPr lang="en-US" dirty="0"/>
               <a:pPr/>
-              <a:t>4/2/26</a:t>
+              <a:t>1/1/2000</a:t>
             </a:fld>
             <a:endParaRPr lang="en-US" dirty="0"/>
           </a:p>
@@ -3975,7 +3991,8 @@
       <p:sp>
         <p:nvSpPr>
           <p:cNvPr id="12" name="Freeform 11"/>
-          <p:cNvSpPr/>
+          <p:cNvSpPr>
+          </p:cNvSpPr>
           <p:nvPr/>
         </p:nvSpPr>
         <p:spPr bwMode="auto">
@@ -3984,10 +4001,6 @@
             <a:ext cx="1588527" cy="507297"/>
           </a:xfrm>
           <a:custGeom>
-            <a:avLst/>
-            <a:gdLst/>
-            <a:ahLst/>
-            <a:cxnLst/>
             <a:rect l="l" t="t" r="r" b="b"/>
             <a:pathLst>
               <a:path w="9248" h="10000">
@@ -4075,7 +4088,7 @@
           <a:lstStyle/>
           <a:p>
             <a:fld id="{D57F1E4F-1CFF-5643-939E-217C01CDF565}" type="slidenum">
-              <a:rPr lang="en-US" dirty="0"/>
+              <a:rPr dirty="0" lang="en-US"/>
               <a:pPr/>
               <a:t>‹#›</a:t>
             </a:fld>
@@ -4127,6 +4140,7 @@
               <a:rPr lang="en-US" dirty="0"/>
               <a:t>Click to edit Master title style</a:t>
             </a:r>
+            <a:endParaRPr lang="en-US" dirty="0"/>
           </a:p>
         </p:txBody>
       </p:sp>
@@ -4148,7 +4162,7 @@
             <a:fld id="{B61BEF0D-F0BB-DE4B-95CE-6DB70DBA9567}" type="datetimeFigureOut">
               <a:rPr lang="en-US" dirty="0"/>
               <a:pPr/>
-              <a:t>4/2/26</a:t>
+              <a:t>1/1/2000</a:t>
             </a:fld>
             <a:endParaRPr lang="en-US" dirty="0"/>
           </a:p>
@@ -4176,7 +4190,8 @@
       <p:sp>
         <p:nvSpPr>
           <p:cNvPr id="7" name="Freeform 11"/>
-          <p:cNvSpPr/>
+          <p:cNvSpPr>
+          </p:cNvSpPr>
           <p:nvPr/>
         </p:nvSpPr>
         <p:spPr bwMode="auto">
@@ -4185,10 +4200,6 @@
             <a:ext cx="1588527" cy="507297"/>
           </a:xfrm>
           <a:custGeom>
-            <a:avLst/>
-            <a:gdLst/>
-            <a:ahLst/>
-            <a:cxnLst/>
             <a:rect l="l" t="t" r="r" b="b"/>
             <a:pathLst>
               <a:path w="9248" h="10000">
@@ -4271,7 +4282,7 @@
           <a:lstStyle/>
           <a:p>
             <a:fld id="{D57F1E4F-1CFF-5643-939E-217C01CDF565}" type="slidenum">
-              <a:rPr lang="en-US" dirty="0"/>
+              <a:rPr dirty="0" lang="en-US"/>
               <a:pPr/>
               <a:t>‹#›</a:t>
             </a:fld>
@@ -4322,7 +4333,7 @@
             <a:fld id="{B61BEF0D-F0BB-DE4B-95CE-6DB70DBA9567}" type="datetimeFigureOut">
               <a:rPr lang="en-US" dirty="0"/>
               <a:pPr/>
-              <a:t>4/2/26</a:t>
+              <a:t>1/1/2000</a:t>
             </a:fld>
             <a:endParaRPr lang="en-US" dirty="0"/>
           </a:p>
@@ -4350,7 +4361,8 @@
       <p:sp>
         <p:nvSpPr>
           <p:cNvPr id="6" name="Freeform 11"/>
-          <p:cNvSpPr/>
+          <p:cNvSpPr>
+          </p:cNvSpPr>
           <p:nvPr/>
         </p:nvSpPr>
         <p:spPr bwMode="auto">
@@ -4359,10 +4371,6 @@
             <a:ext cx="1588527" cy="507297"/>
           </a:xfrm>
           <a:custGeom>
-            <a:avLst/>
-            <a:gdLst/>
-            <a:ahLst/>
-            <a:cxnLst/>
             <a:rect l="l" t="t" r="r" b="b"/>
             <a:pathLst>
               <a:path w="9248" h="10000">
@@ -4445,7 +4453,7 @@
           <a:lstStyle/>
           <a:p>
             <a:fld id="{D57F1E4F-1CFF-5643-939E-217C01CDF565}" type="slidenum">
-              <a:rPr lang="en-US" dirty="0"/>
+              <a:rPr dirty="0" lang="en-US"/>
               <a:pPr/>
               <a:t>‹#›</a:t>
             </a:fld>
@@ -4506,6 +4514,7 @@
               <a:rPr lang="en-US" dirty="0"/>
               <a:t>Click to edit Master title style</a:t>
             </a:r>
+            <a:endParaRPr lang="en-US" dirty="0"/>
           </a:p>
         </p:txBody>
       </p:sp>
@@ -4564,6 +4573,7 @@
               <a:rPr lang="en-US" dirty="0"/>
               <a:t>Fifth level</a:t>
             </a:r>
+            <a:endParaRPr lang="en-US" dirty="0"/>
           </a:p>
         </p:txBody>
       </p:sp>
@@ -4650,7 +4660,7 @@
             <a:fld id="{B61BEF0D-F0BB-DE4B-95CE-6DB70DBA9567}" type="datetimeFigureOut">
               <a:rPr lang="en-US" dirty="0"/>
               <a:pPr/>
-              <a:t>4/2/26</a:t>
+              <a:t>1/1/2000</a:t>
             </a:fld>
             <a:endParaRPr lang="en-US" dirty="0"/>
           </a:p>
@@ -4678,7 +4688,8 @@
       <p:sp>
         <p:nvSpPr>
           <p:cNvPr id="9" name="Freeform 11"/>
-          <p:cNvSpPr/>
+          <p:cNvSpPr>
+          </p:cNvSpPr>
           <p:nvPr/>
         </p:nvSpPr>
         <p:spPr bwMode="auto">
@@ -4687,10 +4698,6 @@
             <a:ext cx="1588527" cy="507297"/>
           </a:xfrm>
           <a:custGeom>
-            <a:avLst/>
-            <a:gdLst/>
-            <a:ahLst/>
-            <a:cxnLst/>
             <a:rect l="l" t="t" r="r" b="b"/>
             <a:pathLst>
               <a:path w="9248" h="10000">
@@ -4773,7 +4780,7 @@
           <a:lstStyle/>
           <a:p>
             <a:fld id="{D57F1E4F-1CFF-5643-939E-217C01CDF565}" type="slidenum">
-              <a:rPr lang="en-US" dirty="0"/>
+              <a:rPr dirty="0" lang="en-US"/>
               <a:pPr/>
               <a:t>‹#›</a:t>
             </a:fld>
@@ -4836,6 +4843,7 @@
               <a:rPr lang="en-US" dirty="0"/>
               <a:t>Click to edit Master title style</a:t>
             </a:r>
+            <a:endParaRPr lang="en-US" dirty="0"/>
           </a:p>
         </p:txBody>
       </p:sp>
@@ -4987,7 +4995,7 @@
             <a:fld id="{B61BEF0D-F0BB-DE4B-95CE-6DB70DBA9567}" type="datetimeFigureOut">
               <a:rPr lang="en-US" dirty="0"/>
               <a:pPr/>
-              <a:t>4/2/26</a:t>
+              <a:t>1/1/2000</a:t>
             </a:fld>
             <a:endParaRPr lang="en-US" dirty="0"/>
           </a:p>
@@ -5015,7 +5023,8 @@
       <p:sp>
         <p:nvSpPr>
           <p:cNvPr id="9" name="Freeform 11"/>
-          <p:cNvSpPr/>
+          <p:cNvSpPr>
+          </p:cNvSpPr>
           <p:nvPr/>
         </p:nvSpPr>
         <p:spPr bwMode="auto">
@@ -5024,10 +5033,6 @@
             <a:ext cx="1588527" cy="507297"/>
           </a:xfrm>
           <a:custGeom>
-            <a:avLst/>
-            <a:gdLst/>
-            <a:ahLst/>
-            <a:cxnLst/>
             <a:rect l="l" t="t" r="r" b="b"/>
             <a:pathLst>
               <a:path w="9248" h="10000">
@@ -5115,7 +5120,7 @@
           <a:lstStyle/>
           <a:p>
             <a:fld id="{D57F1E4F-1CFF-5643-939E-217C01CDF565}" type="slidenum">
-              <a:rPr lang="en-US" dirty="0"/>
+              <a:rPr dirty="0" lang="en-US"/>
               <a:pPr/>
               <a:t>‹#›</a:t>
             </a:fld>
@@ -5170,7 +5175,8 @@
         <p:sp>
           <p:nvSpPr>
             <p:cNvPr id="24" name="Freeform 11"/>
-            <p:cNvSpPr/>
+            <p:cNvSpPr>
+            </p:cNvSpPr>
             <p:nvPr/>
           </p:nvSpPr>
           <p:spPr bwMode="auto">
@@ -5179,10 +5185,6 @@
               <a:ext cx="85725" cy="533400"/>
             </a:xfrm>
             <a:custGeom>
-              <a:avLst/>
-              <a:gdLst/>
-              <a:ahLst/>
-              <a:cxnLst/>
               <a:rect l="0" t="0" r="r" b="b"/>
               <a:pathLst>
                 <a:path w="22" h="136">
@@ -5227,18 +5229,12 @@
               <a:noFill/>
             </a:ln>
           </p:spPr>
-          <p:txBody>
-            <a:bodyPr/>
-            <a:lstStyle/>
-            <a:p>
-              <a:endParaRPr lang="en-US"/>
-            </a:p>
-          </p:txBody>
         </p:sp>
         <p:sp>
           <p:nvSpPr>
             <p:cNvPr id="25" name="Freeform 12"/>
-            <p:cNvSpPr/>
+            <p:cNvSpPr>
+            </p:cNvSpPr>
             <p:nvPr/>
           </p:nvSpPr>
           <p:spPr bwMode="auto">
@@ -5247,10 +5243,6 @@
               <a:ext cx="550863" cy="1978025"/>
             </a:xfrm>
             <a:custGeom>
-              <a:avLst/>
-              <a:gdLst/>
-              <a:ahLst/>
-              <a:cxnLst/>
               <a:rect l="0" t="0" r="r" b="b"/>
               <a:pathLst>
                 <a:path w="140" h="504">
@@ -5300,18 +5292,12 @@
               <a:noFill/>
             </a:ln>
           </p:spPr>
-          <p:txBody>
-            <a:bodyPr/>
-            <a:lstStyle/>
-            <a:p>
-              <a:endParaRPr lang="en-US"/>
-            </a:p>
-          </p:txBody>
         </p:sp>
         <p:sp>
           <p:nvSpPr>
             <p:cNvPr id="26" name="Freeform 13"/>
-            <p:cNvSpPr/>
+            <p:cNvSpPr>
+            </p:cNvSpPr>
             <p:nvPr/>
           </p:nvSpPr>
           <p:spPr bwMode="auto">
@@ -5320,10 +5306,6 @@
               <a:ext cx="519113" cy="1209675"/>
             </a:xfrm>
             <a:custGeom>
-              <a:avLst/>
-              <a:gdLst/>
-              <a:ahLst/>
-              <a:cxnLst/>
               <a:rect l="0" t="0" r="r" b="b"/>
               <a:pathLst>
                 <a:path w="132" h="308">
@@ -5378,18 +5360,12 @@
               <a:noFill/>
             </a:ln>
           </p:spPr>
-          <p:txBody>
-            <a:bodyPr/>
-            <a:lstStyle/>
-            <a:p>
-              <a:endParaRPr lang="en-US"/>
-            </a:p>
-          </p:txBody>
         </p:sp>
         <p:sp>
           <p:nvSpPr>
             <p:cNvPr id="27" name="Freeform 14"/>
-            <p:cNvSpPr/>
+            <p:cNvSpPr>
+            </p:cNvSpPr>
             <p:nvPr/>
           </p:nvSpPr>
           <p:spPr bwMode="auto">
@@ -5398,10 +5374,6 @@
               <a:ext cx="146050" cy="309563"/>
             </a:xfrm>
             <a:custGeom>
-              <a:avLst/>
-              <a:gdLst/>
-              <a:ahLst/>
-              <a:cxnLst/>
               <a:rect l="0" t="0" r="r" b="b"/>
               <a:pathLst>
                 <a:path w="37" h="79">
@@ -5436,18 +5408,12 @@
               <a:noFill/>
             </a:ln>
           </p:spPr>
-          <p:txBody>
-            <a:bodyPr/>
-            <a:lstStyle/>
-            <a:p>
-              <a:endParaRPr lang="en-US"/>
-            </a:p>
-          </p:txBody>
         </p:sp>
         <p:sp>
           <p:nvSpPr>
             <p:cNvPr id="28" name="Freeform 15"/>
-            <p:cNvSpPr/>
+            <p:cNvSpPr>
+            </p:cNvSpPr>
             <p:nvPr/>
           </p:nvSpPr>
           <p:spPr bwMode="auto">
@@ -5456,10 +5422,6 @@
               <a:ext cx="700088" cy="2835275"/>
             </a:xfrm>
             <a:custGeom>
-              <a:avLst/>
-              <a:gdLst/>
-              <a:ahLst/>
-              <a:cxnLst/>
               <a:rect l="0" t="0" r="r" b="b"/>
               <a:pathLst>
                 <a:path w="178" h="722">
@@ -5529,18 +5491,12 @@
               <a:noFill/>
             </a:ln>
           </p:spPr>
-          <p:txBody>
-            <a:bodyPr/>
-            <a:lstStyle/>
-            <a:p>
-              <a:endParaRPr lang="en-US"/>
-            </a:p>
-          </p:txBody>
         </p:sp>
         <p:sp>
           <p:nvSpPr>
             <p:cNvPr id="29" name="Freeform 16"/>
-            <p:cNvSpPr/>
+            <p:cNvSpPr>
+            </p:cNvSpPr>
             <p:nvPr/>
           </p:nvSpPr>
           <p:spPr bwMode="auto">
@@ -5549,10 +5505,6 @@
               <a:ext cx="90488" cy="2493963"/>
             </a:xfrm>
             <a:custGeom>
-              <a:avLst/>
-              <a:gdLst/>
-              <a:ahLst/>
-              <a:cxnLst/>
               <a:rect l="0" t="0" r="r" b="b"/>
               <a:pathLst>
                 <a:path w="23" h="635">
@@ -5617,18 +5569,12 @@
               <a:noFill/>
             </a:ln>
           </p:spPr>
-          <p:txBody>
-            <a:bodyPr/>
-            <a:lstStyle/>
-            <a:p>
-              <a:endParaRPr lang="en-US"/>
-            </a:p>
-          </p:txBody>
         </p:sp>
         <p:sp>
           <p:nvSpPr>
             <p:cNvPr id="30" name="Freeform 17"/>
-            <p:cNvSpPr/>
+            <p:cNvSpPr>
+            </p:cNvSpPr>
             <p:nvPr/>
           </p:nvSpPr>
           <p:spPr bwMode="auto">
@@ -5637,10 +5583,6 @@
               <a:ext cx="66675" cy="420688"/>
             </a:xfrm>
             <a:custGeom>
-              <a:avLst/>
-              <a:gdLst/>
-              <a:ahLst/>
-              <a:cxnLst/>
               <a:rect l="0" t="0" r="r" b="b"/>
               <a:pathLst>
                 <a:path w="17" h="107">
@@ -5685,18 +5627,12 @@
               <a:noFill/>
             </a:ln>
           </p:spPr>
-          <p:txBody>
-            <a:bodyPr/>
-            <a:lstStyle/>
-            <a:p>
-              <a:endParaRPr lang="en-US"/>
-            </a:p>
-          </p:txBody>
         </p:sp>
         <p:sp>
           <p:nvSpPr>
             <p:cNvPr id="31" name="Freeform 18"/>
-            <p:cNvSpPr/>
+            <p:cNvSpPr>
+            </p:cNvSpPr>
             <p:nvPr/>
           </p:nvSpPr>
           <p:spPr bwMode="auto">
@@ -5705,10 +5641,6 @@
               <a:ext cx="161925" cy="873125"/>
             </a:xfrm>
             <a:custGeom>
-              <a:avLst/>
-              <a:gdLst/>
-              <a:ahLst/>
-              <a:cxnLst/>
               <a:rect l="0" t="0" r="r" b="b"/>
               <a:pathLst>
                 <a:path w="41" h="222">
@@ -5773,18 +5705,12 @@
               <a:noFill/>
             </a:ln>
           </p:spPr>
-          <p:txBody>
-            <a:bodyPr/>
-            <a:lstStyle/>
-            <a:p>
-              <a:endParaRPr lang="en-US"/>
-            </a:p>
-          </p:txBody>
         </p:sp>
         <p:sp>
           <p:nvSpPr>
             <p:cNvPr id="32" name="Freeform 19"/>
-            <p:cNvSpPr/>
+            <p:cNvSpPr>
+            </p:cNvSpPr>
             <p:nvPr/>
           </p:nvSpPr>
           <p:spPr bwMode="auto">
@@ -5793,10 +5719,6 @@
               <a:ext cx="1768475" cy="3448050"/>
             </a:xfrm>
             <a:custGeom>
-              <a:avLst/>
-              <a:gdLst/>
-              <a:ahLst/>
-              <a:cxnLst/>
               <a:rect l="0" t="0" r="r" b="b"/>
               <a:pathLst>
                 <a:path w="450" h="878">
@@ -5896,18 +5818,12 @@
               <a:noFill/>
             </a:ln>
           </p:spPr>
-          <p:txBody>
-            <a:bodyPr/>
-            <a:lstStyle/>
-            <a:p>
-              <a:endParaRPr lang="en-US"/>
-            </a:p>
-          </p:txBody>
         </p:sp>
         <p:sp>
           <p:nvSpPr>
             <p:cNvPr id="33" name="Freeform 20"/>
-            <p:cNvSpPr/>
+            <p:cNvSpPr>
+            </p:cNvSpPr>
             <p:nvPr/>
           </p:nvSpPr>
           <p:spPr bwMode="auto">
@@ -5916,10 +5832,6 @@
               <a:ext cx="138113" cy="287338"/>
             </a:xfrm>
             <a:custGeom>
-              <a:avLst/>
-              <a:gdLst/>
-              <a:ahLst/>
-              <a:cxnLst/>
               <a:rect l="0" t="0" r="r" b="b"/>
               <a:pathLst>
                 <a:path w="35" h="73">
@@ -5954,18 +5866,12 @@
               <a:noFill/>
             </a:ln>
           </p:spPr>
-          <p:txBody>
-            <a:bodyPr/>
-            <a:lstStyle/>
-            <a:p>
-              <a:endParaRPr lang="en-US"/>
-            </a:p>
-          </p:txBody>
         </p:sp>
         <p:sp>
           <p:nvSpPr>
             <p:cNvPr id="34" name="Freeform 21"/>
-            <p:cNvSpPr/>
+            <p:cNvSpPr>
+            </p:cNvSpPr>
             <p:nvPr/>
           </p:nvSpPr>
           <p:spPr bwMode="auto">
@@ -5974,10 +5880,6 @@
               <a:ext cx="31750" cy="188913"/>
             </a:xfrm>
             <a:custGeom>
-              <a:avLst/>
-              <a:gdLst/>
-              <a:ahLst/>
-              <a:cxnLst/>
               <a:rect l="0" t="0" r="r" b="b"/>
               <a:pathLst>
                 <a:path w="8" h="48">
@@ -6022,18 +5924,12 @@
               <a:noFill/>
             </a:ln>
           </p:spPr>
-          <p:txBody>
-            <a:bodyPr/>
-            <a:lstStyle/>
-            <a:p>
-              <a:endParaRPr lang="en-US"/>
-            </a:p>
-          </p:txBody>
         </p:sp>
         <p:sp>
           <p:nvSpPr>
             <p:cNvPr id="35" name="Freeform 22"/>
-            <p:cNvSpPr/>
+            <p:cNvSpPr>
+            </p:cNvSpPr>
             <p:nvPr/>
           </p:nvSpPr>
           <p:spPr bwMode="auto">
@@ -6042,10 +5938,6 @@
               <a:ext cx="203200" cy="530225"/>
             </a:xfrm>
             <a:custGeom>
-              <a:avLst/>
-              <a:gdLst/>
-              <a:ahLst/>
-              <a:cxnLst/>
               <a:rect l="0" t="0" r="r" b="b"/>
               <a:pathLst>
                 <a:path w="52" h="135">
@@ -6100,13 +5992,6 @@
               <a:noFill/>
             </a:ln>
           </p:spPr>
-          <p:txBody>
-            <a:bodyPr/>
-            <a:lstStyle/>
-            <a:p>
-              <a:endParaRPr lang="en-US"/>
-            </a:p>
-          </p:txBody>
         </p:sp>
       </p:grpSp>
       <p:grpSp>
@@ -6126,7 +6011,8 @@
         <p:sp>
           <p:nvSpPr>
             <p:cNvPr id="11" name="Freeform 27"/>
-            <p:cNvSpPr/>
+            <p:cNvSpPr>
+            </p:cNvSpPr>
             <p:nvPr/>
           </p:nvSpPr>
           <p:spPr bwMode="auto">
@@ -6135,10 +6021,6 @@
               <a:ext cx="409575" cy="3646488"/>
             </a:xfrm>
             <a:custGeom>
-              <a:avLst/>
-              <a:gdLst/>
-              <a:ahLst/>
-              <a:cxnLst/>
               <a:rect l="0" t="0" r="r" b="b"/>
               <a:pathLst>
                 <a:path w="103" h="920">
@@ -6226,18 +6108,12 @@
               <a:noFill/>
             </a:ln>
           </p:spPr>
-          <p:txBody>
-            <a:bodyPr/>
-            <a:lstStyle/>
-            <a:p>
-              <a:endParaRPr lang="en-US"/>
-            </a:p>
-          </p:txBody>
         </p:sp>
         <p:sp>
           <p:nvSpPr>
             <p:cNvPr id="12" name="Freeform 28"/>
-            <p:cNvSpPr/>
+            <p:cNvSpPr>
+            </p:cNvSpPr>
             <p:nvPr/>
           </p:nvSpPr>
           <p:spPr bwMode="auto">
@@ -6246,10 +6122,6 @@
               <a:ext cx="350838" cy="1309688"/>
             </a:xfrm>
             <a:custGeom>
-              <a:avLst/>
-              <a:gdLst/>
-              <a:ahLst/>
-              <a:cxnLst/>
               <a:rect l="0" t="0" r="r" b="b"/>
               <a:pathLst>
                 <a:path w="88" h="330">
@@ -6302,18 +6174,12 @@
               <a:noFill/>
             </a:ln>
           </p:spPr>
-          <p:txBody>
-            <a:bodyPr/>
-            <a:lstStyle/>
-            <a:p>
-              <a:endParaRPr lang="en-US"/>
-            </a:p>
-          </p:txBody>
         </p:sp>
         <p:sp>
           <p:nvSpPr>
             <p:cNvPr id="13" name="Freeform 29"/>
-            <p:cNvSpPr/>
+            <p:cNvSpPr>
+            </p:cNvSpPr>
             <p:nvPr/>
           </p:nvSpPr>
           <p:spPr bwMode="auto">
@@ -6322,10 +6188,6 @@
               <a:ext cx="357188" cy="820738"/>
             </a:xfrm>
             <a:custGeom>
-              <a:avLst/>
-              <a:gdLst/>
-              <a:ahLst/>
-              <a:cxnLst/>
               <a:rect l="0" t="0" r="r" b="b"/>
               <a:pathLst>
                 <a:path w="90" h="207">
@@ -6378,18 +6240,12 @@
               <a:noFill/>
             </a:ln>
           </p:spPr>
-          <p:txBody>
-            <a:bodyPr/>
-            <a:lstStyle/>
-            <a:p>
-              <a:endParaRPr lang="en-US"/>
-            </a:p>
-          </p:txBody>
         </p:sp>
         <p:sp>
           <p:nvSpPr>
             <p:cNvPr id="14" name="Freeform 30"/>
-            <p:cNvSpPr/>
+            <p:cNvSpPr>
+            </p:cNvSpPr>
             <p:nvPr/>
           </p:nvSpPr>
           <p:spPr bwMode="auto">
@@ -6398,10 +6254,6 @@
               <a:ext cx="457200" cy="1852613"/>
             </a:xfrm>
             <a:custGeom>
-              <a:avLst/>
-              <a:gdLst/>
-              <a:ahLst/>
-              <a:cxnLst/>
               <a:rect l="0" t="0" r="r" b="b"/>
               <a:pathLst>
                 <a:path w="115" h="467">
@@ -6469,18 +6321,12 @@
               <a:noFill/>
             </a:ln>
           </p:spPr>
-          <p:txBody>
-            <a:bodyPr/>
-            <a:lstStyle/>
-            <a:p>
-              <a:endParaRPr lang="en-US"/>
-            </a:p>
-          </p:txBody>
         </p:sp>
         <p:sp>
           <p:nvSpPr>
             <p:cNvPr id="15" name="Freeform 31"/>
-            <p:cNvSpPr/>
+            <p:cNvSpPr>
+            </p:cNvSpPr>
             <p:nvPr/>
           </p:nvSpPr>
           <p:spPr bwMode="auto">
@@ -6489,10 +6335,6 @@
               <a:ext cx="144463" cy="2508250"/>
             </a:xfrm>
             <a:custGeom>
-              <a:avLst/>
-              <a:gdLst/>
-              <a:ahLst/>
-              <a:cxnLst/>
               <a:rect l="0" t="0" r="r" b="b"/>
               <a:pathLst>
                 <a:path w="36" h="633">
@@ -6570,18 +6412,12 @@
               <a:noFill/>
             </a:ln>
           </p:spPr>
-          <p:txBody>
-            <a:bodyPr/>
-            <a:lstStyle/>
-            <a:p>
-              <a:endParaRPr lang="en-US"/>
-            </a:p>
-          </p:txBody>
         </p:sp>
         <p:sp>
           <p:nvSpPr>
             <p:cNvPr id="16" name="Freeform 32"/>
-            <p:cNvSpPr/>
+            <p:cNvSpPr>
+            </p:cNvSpPr>
             <p:nvPr/>
           </p:nvSpPr>
           <p:spPr bwMode="auto">
@@ -6590,10 +6426,6 @@
               <a:ext cx="111125" cy="233363"/>
             </a:xfrm>
             <a:custGeom>
-              <a:avLst/>
-              <a:gdLst/>
-              <a:ahLst/>
-              <a:cxnLst/>
               <a:rect l="0" t="0" r="r" b="b"/>
               <a:pathLst>
                 <a:path w="28" h="59">
@@ -6626,18 +6458,12 @@
               <a:noFill/>
             </a:ln>
           </p:spPr>
-          <p:txBody>
-            <a:bodyPr/>
-            <a:lstStyle/>
-            <a:p>
-              <a:endParaRPr lang="en-US"/>
-            </a:p>
-          </p:txBody>
         </p:sp>
         <p:sp>
           <p:nvSpPr>
             <p:cNvPr id="17" name="Freeform 33"/>
-            <p:cNvSpPr/>
+            <p:cNvSpPr>
+            </p:cNvSpPr>
             <p:nvPr/>
           </p:nvSpPr>
           <p:spPr bwMode="auto">
@@ -6646,10 +6472,6 @@
               <a:ext cx="68263" cy="423863"/>
             </a:xfrm>
             <a:custGeom>
-              <a:avLst/>
-              <a:gdLst/>
-              <a:ahLst/>
-              <a:cxnLst/>
               <a:rect l="0" t="0" r="r" b="b"/>
               <a:pathLst>
                 <a:path w="17" h="107">
@@ -6697,18 +6519,12 @@
               <a:noFill/>
             </a:ln>
           </p:spPr>
-          <p:txBody>
-            <a:bodyPr/>
-            <a:lstStyle/>
-            <a:p>
-              <a:endParaRPr lang="en-US"/>
-            </a:p>
-          </p:txBody>
         </p:sp>
         <p:sp>
           <p:nvSpPr>
             <p:cNvPr id="18" name="Freeform 34"/>
-            <p:cNvSpPr/>
+            <p:cNvSpPr>
+            </p:cNvSpPr>
             <p:nvPr/>
           </p:nvSpPr>
           <p:spPr bwMode="auto">
@@ -6717,10 +6533,6 @@
               <a:ext cx="1168400" cy="2251075"/>
             </a:xfrm>
             <a:custGeom>
-              <a:avLst/>
-              <a:gdLst/>
-              <a:ahLst/>
-              <a:cxnLst/>
               <a:rect l="0" t="0" r="r" b="b"/>
               <a:pathLst>
                 <a:path w="294" h="568">
@@ -6813,18 +6625,12 @@
               <a:noFill/>
             </a:ln>
           </p:spPr>
-          <p:txBody>
-            <a:bodyPr/>
-            <a:lstStyle/>
-            <a:p>
-              <a:endParaRPr lang="en-US"/>
-            </a:p>
-          </p:txBody>
         </p:sp>
         <p:sp>
           <p:nvSpPr>
             <p:cNvPr id="19" name="Freeform 35"/>
-            <p:cNvSpPr/>
+            <p:cNvSpPr>
+            </p:cNvSpPr>
             <p:nvPr/>
           </p:nvSpPr>
           <p:spPr bwMode="auto">
@@ -6833,10 +6639,6 @@
               <a:ext cx="100013" cy="209550"/>
             </a:xfrm>
             <a:custGeom>
-              <a:avLst/>
-              <a:gdLst/>
-              <a:ahLst/>
-              <a:cxnLst/>
               <a:rect l="0" t="0" r="r" b="b"/>
               <a:pathLst>
                 <a:path w="25" h="53">
@@ -6869,18 +6671,12 @@
               <a:noFill/>
             </a:ln>
           </p:spPr>
-          <p:txBody>
-            <a:bodyPr/>
-            <a:lstStyle/>
-            <a:p>
-              <a:endParaRPr lang="en-US"/>
-            </a:p>
-          </p:txBody>
         </p:sp>
         <p:sp>
           <p:nvSpPr>
             <p:cNvPr id="20" name="Freeform 36"/>
-            <p:cNvSpPr/>
+            <p:cNvSpPr>
+            </p:cNvSpPr>
             <p:nvPr/>
           </p:nvSpPr>
           <p:spPr bwMode="auto">
@@ -6889,10 +6685,6 @@
               <a:ext cx="114300" cy="558800"/>
             </a:xfrm>
             <a:custGeom>
-              <a:avLst/>
-              <a:gdLst/>
-              <a:ahLst/>
-              <a:cxnLst/>
               <a:rect l="0" t="0" r="r" b="b"/>
               <a:pathLst>
                 <a:path w="29" h="141">
@@ -6945,18 +6737,12 @@
               <a:noFill/>
             </a:ln>
           </p:spPr>
-          <p:txBody>
-            <a:bodyPr/>
-            <a:lstStyle/>
-            <a:p>
-              <a:endParaRPr lang="en-US"/>
-            </a:p>
-          </p:txBody>
         </p:sp>
         <p:sp>
           <p:nvSpPr>
             <p:cNvPr id="21" name="Freeform 37"/>
-            <p:cNvSpPr/>
+            <p:cNvSpPr>
+            </p:cNvSpPr>
             <p:nvPr/>
           </p:nvSpPr>
           <p:spPr bwMode="auto">
@@ -6965,10 +6751,6 @@
               <a:ext cx="31750" cy="188913"/>
             </a:xfrm>
             <a:custGeom>
-              <a:avLst/>
-              <a:gdLst/>
-              <a:ahLst/>
-              <a:cxnLst/>
               <a:rect l="0" t="0" r="r" b="b"/>
               <a:pathLst>
                 <a:path w="8" h="48">
@@ -7016,18 +6798,12 @@
               <a:noFill/>
             </a:ln>
           </p:spPr>
-          <p:txBody>
-            <a:bodyPr/>
-            <a:lstStyle/>
-            <a:p>
-              <a:endParaRPr lang="en-US"/>
-            </a:p>
-          </p:txBody>
         </p:sp>
         <p:sp>
           <p:nvSpPr>
             <p:cNvPr id="22" name="Freeform 38"/>
-            <p:cNvSpPr/>
+            <p:cNvSpPr>
+            </p:cNvSpPr>
             <p:nvPr/>
           </p:nvSpPr>
           <p:spPr bwMode="auto">
@@ -7036,10 +6812,6 @@
               <a:ext cx="174625" cy="439738"/>
             </a:xfrm>
             <a:custGeom>
-              <a:avLst/>
-              <a:gdLst/>
-              <a:ahLst/>
-              <a:cxnLst/>
               <a:rect l="0" t="0" r="r" b="b"/>
               <a:pathLst>
                 <a:path w="44" h="111">
@@ -7092,13 +6864,6 @@
               <a:noFill/>
             </a:ln>
           </p:spPr>
-          <p:txBody>
-            <a:bodyPr/>
-            <a:lstStyle/>
-            <a:p>
-              <a:endParaRPr lang="en-US"/>
-            </a:p>
-          </p:txBody>
         </p:sp>
       </p:grpSp>
       <p:sp>
@@ -7113,7 +6878,6 @@
             <a:ext cx="182880" cy="6858000"/>
           </a:xfrm>
           <a:prstGeom prst="rect">
-            <a:avLst/>
           </a:prstGeom>
           <a:solidFill>
             <a:schemeClr val="tx2"/>
@@ -7137,13 +6901,6 @@
             <a:schemeClr val="lt1"/>
           </a:fontRef>
         </p:style>
-        <p:txBody>
-          <a:bodyPr/>
-          <a:lstStyle/>
-          <a:p>
-            <a:endParaRPr lang="en-US"/>
-          </a:p>
-        </p:txBody>
       </p:sp>
       <p:sp>
         <p:nvSpPr>
@@ -7161,7 +6918,6 @@
             <a:ext cx="8911687" cy="1280890"/>
           </a:xfrm>
           <a:prstGeom prst="rect">
-            <a:avLst/>
           </a:prstGeom>
         </p:spPr>
         <p:txBody>
@@ -7174,6 +6930,7 @@
               <a:rPr lang="en-US" dirty="0"/>
               <a:t>Click to edit Master title style</a:t>
             </a:r>
+            <a:endParaRPr lang="en-US" dirty="0"/>
           </a:p>
         </p:txBody>
       </p:sp>
@@ -7193,7 +6950,6 @@
             <a:ext cx="8915400" cy="3886200"/>
           </a:xfrm>
           <a:prstGeom prst="rect">
-            <a:avLst/>
           </a:prstGeom>
         </p:spPr>
         <p:txBody>
@@ -7235,6 +6991,7 @@
               <a:rPr lang="en-US" dirty="0"/>
               <a:t>Fifth level</a:t>
             </a:r>
+            <a:endParaRPr lang="en-US" dirty="0"/>
           </a:p>
         </p:txBody>
       </p:sp>
@@ -7254,7 +7011,6 @@
             <a:ext cx="1146283" cy="370396"/>
           </a:xfrm>
           <a:prstGeom prst="rect">
-            <a:avLst/>
           </a:prstGeom>
         </p:spPr>
         <p:txBody>
@@ -7274,7 +7030,7 @@
             <a:fld id="{B61BEF0D-F0BB-DE4B-95CE-6DB70DBA9567}" type="datetimeFigureOut">
               <a:rPr lang="en-US" dirty="0"/>
               <a:pPr/>
-              <a:t>4/2/26</a:t>
+              <a:t>1/1/2000</a:t>
             </a:fld>
             <a:endParaRPr lang="en-US" dirty="0"/>
           </a:p>
@@ -7296,7 +7052,6 @@
             <a:ext cx="7619999" cy="365125"/>
           </a:xfrm>
           <a:prstGeom prst="rect">
-            <a:avLst/>
           </a:prstGeom>
         </p:spPr>
         <p:txBody>
@@ -7333,7 +7088,6 @@
             <a:ext cx="779767" cy="365125"/>
           </a:xfrm>
           <a:prstGeom prst="rect">
-            <a:avLst/>
           </a:prstGeom>
         </p:spPr>
         <p:txBody>
@@ -7772,7 +7526,7 @@
 </file>
 
 <file path=ppt/slides/slide1.xml><?xml version="1.0" encoding="utf-8"?>
-<p:sld xmlns:a="http://schemas.openxmlformats.org/drawingml/2006/main" xmlns:r="http://schemas.openxmlformats.org/officeDocument/2006/relationships" xmlns:p="http://schemas.openxmlformats.org/presentationml/2006/main">
+<p:sld xmlns:a="http://schemas.openxmlformats.org/drawingml/2006/main" xmlns:p="http://schemas.openxmlformats.org/presentationml/2006/main" xmlns:r="http://schemas.openxmlformats.org/officeDocument/2006/relationships">
   <p:cSld>
     <p:spTree>
       <p:nvGrpSpPr>
@@ -7780,14 +7534,7 @@
         <p:cNvGrpSpPr/>
         <p:nvPr/>
       </p:nvGrpSpPr>
-      <p:grpSpPr>
-        <a:xfrm>
-          <a:off x="0" y="0"/>
-          <a:ext cx="0" cy="0"/>
-          <a:chOff x="0" y="0"/>
-          <a:chExt cx="0" cy="0"/>
-        </a:xfrm>
-      </p:grpSpPr>
+      <p:grpSpPr/>
       <p:sp>
         <p:nvSpPr>
           <p:cNvPr id="2" name="Title 1"/>
@@ -7805,22 +7552,8 @@
           <a:p>
             <a:pPr algn="l"/>
             <a:r>
-              <a:rPr dirty="0"/>
-              <a:t>CL</a:t>
-            </a:r>
-            <a:r>
-              <a:rPr lang="en-US" dirty="0"/>
-              <a:t> </a:t>
-            </a:r>
-            <a:r>
-              <a:rPr dirty="0"/>
-              <a:t>Prompter</a:t>
-            </a:r>
-            <a:r>
-              <a:rPr lang="en-US" dirty="0"/>
-              <a:t> for VS CODE</a:t>
-            </a:r>
-            <a:endParaRPr dirty="0"/>
+              <a:t>CLPrompter: Prompt CL Commands Like IBM i F4 — in VS Code</a:t>
+            </a:r>
           </a:p>
         </p:txBody>
       </p:sp>
@@ -7841,9 +7574,7 @@
           </a:xfrm>
         </p:spPr>
         <p:txBody>
-          <a:bodyPr wrap="square" lIns="109728" tIns="91440" rIns="109728" bIns="91440">
-            <a:normAutofit/>
-          </a:bodyPr>
+          <a:bodyPr wrap="square" lIns="109728" rIns="109728" tIns="91440" bIns="91440"/>
           <a:lstStyle/>
           <a:p>
             <a:pPr>
@@ -7855,34 +7586,16 @@
               </a:spcAft>
             </a:pPr>
             <a:r>
-              <a:rPr sz="2400" b="0" i="0" dirty="0">
-                <a:solidFill>
-                  <a:srgbClr val="1A1A2E"/>
-                </a:solidFill>
-                <a:latin typeface="Calibri"/>
-              </a:rPr>
-              <a:t>Brings the classic IBM </a:t>
-            </a:r>
-            <a:r>
-              <a:rPr sz="2400" b="0" i="0" dirty="0" err="1">
-                <a:solidFill>
-                  <a:srgbClr val="1A1A2E"/>
-                </a:solidFill>
-                <a:latin typeface="Calibri"/>
-              </a:rPr>
-              <a:t>i</a:t>
-            </a:r>
-            <a:r>
-              <a:rPr sz="2400" b="0" i="0" dirty="0">
-                <a:solidFill>
-                  <a:srgbClr val="1A1A2E"/>
-                </a:solidFill>
-                <a:latin typeface="Calibri"/>
-              </a:rPr>
-              <a:t> </a:t>
-            </a:r>
-            <a:r>
-              <a:rPr sz="2400" b="1" i="0" dirty="0">
+              <a:rPr sz="1500" b="0" i="0">
+                <a:solidFill>
+                  <a:srgbClr val="1A1A2E"/>
+                </a:solidFill>
+                <a:latin typeface="Calibri"/>
+              </a:rPr>
+              <a:t>Brings the classic IBM i </a:t>
+            </a:r>
+            <a:r>
+              <a:rPr sz="1500" b="1" i="0">
                 <a:solidFill>
                   <a:srgbClr val="1F497D"/>
                 </a:solidFill>
@@ -7891,7 +7604,7 @@
               <a:t>F4=Prompt</a:t>
             </a:r>
             <a:r>
-              <a:rPr sz="2400" b="0" i="0" dirty="0">
+              <a:rPr sz="1500" b="0" i="0">
                 <a:solidFill>
                   <a:srgbClr val="1A1A2E"/>
                 </a:solidFill>
@@ -7910,7 +7623,7 @@
               </a:spcAft>
             </a:pPr>
             <a:r>
-              <a:rPr sz="2400" b="0" i="0" dirty="0">
+              <a:rPr sz="1500" b="0" i="0">
                 <a:solidFill>
                   <a:srgbClr val="1A1A2E"/>
                 </a:solidFill>
@@ -7919,7 +7632,7 @@
               <a:t>Works on </a:t>
             </a:r>
             <a:r>
-              <a:rPr sz="2400" b="0" i="0" dirty="0">
+              <a:rPr sz="1300" b="0" i="0">
                 <a:solidFill>
                   <a:srgbClr val="B5204F"/>
                 </a:solidFill>
@@ -7928,7 +7641,7 @@
               <a:t>.cl</a:t>
             </a:r>
             <a:r>
-              <a:rPr sz="2400" b="0" i="0" dirty="0">
+              <a:rPr sz="1500" b="0" i="0">
                 <a:solidFill>
                   <a:srgbClr val="1A1A2E"/>
                 </a:solidFill>
@@ -7937,79 +7650,52 @@
               <a:t>, </a:t>
             </a:r>
             <a:r>
-              <a:rPr sz="2400" b="0" i="0" dirty="0">
+              <a:rPr sz="1300" b="0" i="0">
                 <a:solidFill>
                   <a:srgbClr val="B5204F"/>
                 </a:solidFill>
                 <a:latin typeface="Courier New"/>
               </a:rPr>
-              <a:t>.</a:t>
-            </a:r>
-            <a:r>
-              <a:rPr sz="2400" b="0" i="0" dirty="0" err="1">
+              <a:t>.clle</a:t>
+            </a:r>
+            <a:r>
+              <a:rPr sz="1500" b="0" i="0">
+                <a:solidFill>
+                  <a:srgbClr val="1A1A2E"/>
+                </a:solidFill>
+                <a:latin typeface="Calibri"/>
+              </a:rPr>
+              <a:t>, </a:t>
+            </a:r>
+            <a:r>
+              <a:rPr sz="1300" b="0" i="0">
                 <a:solidFill>
                   <a:srgbClr val="B5204F"/>
                 </a:solidFill>
                 <a:latin typeface="Courier New"/>
               </a:rPr>
-              <a:t>clle</a:t>
-            </a:r>
-            <a:r>
-              <a:rPr sz="2400" b="0" i="0" dirty="0">
-                <a:solidFill>
-                  <a:srgbClr val="1A1A2E"/>
-                </a:solidFill>
-                <a:latin typeface="Calibri"/>
-              </a:rPr>
-              <a:t>, </a:t>
-            </a:r>
-            <a:r>
-              <a:rPr sz="2400" b="0" i="0" dirty="0">
+              <a:t>.cmd</a:t>
+            </a:r>
+            <a:r>
+              <a:rPr sz="1500" b="0" i="0">
+                <a:solidFill>
+                  <a:srgbClr val="1A1A2E"/>
+                </a:solidFill>
+                <a:latin typeface="Calibri"/>
+              </a:rPr>
+              <a:t>, and </a:t>
+            </a:r>
+            <a:r>
+              <a:rPr sz="1300" b="0" i="0">
                 <a:solidFill>
                   <a:srgbClr val="B5204F"/>
                 </a:solidFill>
                 <a:latin typeface="Courier New"/>
               </a:rPr>
-              <a:t>.</a:t>
-            </a:r>
-            <a:r>
-              <a:rPr sz="2400" b="0" i="0" dirty="0" err="1">
-                <a:solidFill>
-                  <a:srgbClr val="B5204F"/>
-                </a:solidFill>
-                <a:latin typeface="Courier New"/>
-              </a:rPr>
-              <a:t>cmd</a:t>
-            </a:r>
-            <a:r>
-              <a:rPr sz="2400" b="0" i="0" dirty="0">
-                <a:solidFill>
-                  <a:srgbClr val="1A1A2E"/>
-                </a:solidFill>
-                <a:latin typeface="Calibri"/>
-              </a:rPr>
-              <a:t>, and </a:t>
-            </a:r>
-            <a:r>
-              <a:rPr sz="2400" b="0" i="0" dirty="0">
-                <a:solidFill>
-                  <a:srgbClr val="B5204F"/>
-                </a:solidFill>
-                <a:latin typeface="Courier New"/>
-              </a:rPr>
-              <a:t>.</a:t>
-            </a:r>
-            <a:r>
-              <a:rPr sz="2400" b="0" i="0" dirty="0" err="1">
-                <a:solidFill>
-                  <a:srgbClr val="B5204F"/>
-                </a:solidFill>
-                <a:latin typeface="Courier New"/>
-              </a:rPr>
-              <a:t>bnd</a:t>
-            </a:r>
-            <a:r>
-              <a:rPr sz="2400" b="0" i="0" dirty="0">
+              <a:t>.bnd</a:t>
+            </a:r>
+            <a:r>
+              <a:rPr sz="1500" b="0" i="0">
                 <a:solidFill>
                   <a:srgbClr val="1A1A2E"/>
                 </a:solidFill>
@@ -8028,7 +7714,7 @@
               </a:spcAft>
             </a:pPr>
             <a:r>
-              <a:rPr sz="2400" b="0" i="0" dirty="0">
+              <a:rPr sz="1500" b="0" i="0">
                 <a:solidFill>
                   <a:srgbClr val="1A1A2E"/>
                 </a:solidFill>
@@ -8037,47 +7723,23 @@
               <a:t>Integrates with </a:t>
             </a:r>
             <a:r>
-              <a:rPr sz="2400" b="1" i="0" dirty="0">
+              <a:rPr sz="1500" b="1" i="0">
                 <a:solidFill>
                   <a:srgbClr val="1F497D"/>
                 </a:solidFill>
                 <a:latin typeface="Calibri"/>
               </a:rPr>
-              <a:t>Code for IBM </a:t>
-            </a:r>
-            <a:r>
-              <a:rPr sz="2400" b="1" i="0" dirty="0" err="1">
-                <a:solidFill>
-                  <a:srgbClr val="1F497D"/>
-                </a:solidFill>
-                <a:latin typeface="Calibri"/>
-              </a:rPr>
-              <a:t>i</a:t>
-            </a:r>
-            <a:r>
-              <a:rPr sz="2400" b="0" i="0" dirty="0">
-                <a:solidFill>
-                  <a:srgbClr val="1A1A2E"/>
-                </a:solidFill>
-                <a:latin typeface="Calibri"/>
-              </a:rPr>
-              <a:t> for command </a:t>
-            </a:r>
-            <a:r>
-              <a:rPr lang="en-US" sz="2400" b="0" i="0" dirty="0">
-                <a:solidFill>
-                  <a:srgbClr val="1A1A2E"/>
-                </a:solidFill>
-                <a:latin typeface="Calibri"/>
-              </a:rPr>
-              <a:t>entry</a:t>
-            </a:r>
-            <a:endParaRPr sz="2400" b="0" i="0" dirty="0">
-              <a:solidFill>
-                <a:srgbClr val="1A1A2E"/>
-              </a:solidFill>
-              <a:latin typeface="Calibri"/>
-            </a:endParaRPr>
+              <a:t>Code for IBM i</a:t>
+            </a:r>
+            <a:r>
+              <a:rPr sz="1500" b="0" i="0">
+                <a:solidFill>
+                  <a:srgbClr val="1A1A2E"/>
+                </a:solidFill>
+                <a:latin typeface="Calibri"/>
+              </a:rPr>
+              <a:t> for live IBM i command definitions</a:t>
+            </a:r>
           </a:p>
           <a:p>
             <a:pPr>
@@ -8089,29 +7751,14 @@
               </a:spcAft>
             </a:pPr>
             <a:r>
-              <a:rPr sz="2400" b="0" i="0" dirty="0">
-                <a:solidFill>
-                  <a:srgbClr val="1A1A2E"/>
-                </a:solidFill>
-                <a:latin typeface="Calibri"/>
-              </a:rPr>
-              <a:t>By Bob Cozzi / </a:t>
-            </a:r>
-            <a:r>
-              <a:rPr sz="2400" b="0" i="0" dirty="0" err="1">
-                <a:solidFill>
-                  <a:srgbClr val="1A1A2E"/>
-                </a:solidFill>
-                <a:latin typeface="Calibri"/>
-              </a:rPr>
-              <a:t>CozziResearch</a:t>
-            </a:r>
-            <a:endParaRPr sz="2400" b="0" i="0" dirty="0">
-              <a:solidFill>
-                <a:srgbClr val="1A1A2E"/>
-              </a:solidFill>
-              <a:latin typeface="Calibri"/>
-            </a:endParaRPr>
+              <a:rPr sz="1500" b="0" i="0">
+                <a:solidFill>
+                  <a:srgbClr val="1A1A2E"/>
+                </a:solidFill>
+                <a:latin typeface="Calibri"/>
+              </a:rPr>
+              <a:t>By Bob Cozzi / CozziResearch</a:t>
+            </a:r>
           </a:p>
           <a:p>
             <a:pPr>
@@ -8123,7 +7770,7 @@
               </a:spcAft>
             </a:pPr>
             <a:r>
-              <a:rPr sz="2400" b="0" i="0" dirty="0">
+              <a:rPr sz="1500" b="0" i="0">
                 <a:solidFill>
                   <a:srgbClr val="1A1A2E"/>
                 </a:solidFill>
@@ -8132,7 +7779,7 @@
               <a:t>Currently in </a:t>
             </a:r>
             <a:r>
-              <a:rPr sz="2400" b="1" i="0" dirty="0">
+              <a:rPr sz="1500" b="1" i="0">
                 <a:solidFill>
                   <a:srgbClr val="1F497D"/>
                 </a:solidFill>
@@ -8141,128 +7788,14 @@
               <a:t>PREVIEW</a:t>
             </a:r>
             <a:r>
-              <a:rPr lang="en-US" sz="2400" dirty="0">
-                <a:solidFill>
-                  <a:srgbClr val="1A1A2E"/>
-                </a:solidFill>
-                <a:latin typeface="Calibri"/>
-              </a:rPr>
-              <a:t> </a:t>
-            </a:r>
-          </a:p>
-          <a:p>
-            <a:pPr lvl="1">
-              <a:spcBef>
-                <a:spcPts val="400"/>
-              </a:spcBef>
-              <a:spcAft>
-                <a:spcPts val="200"/>
-              </a:spcAft>
-            </a:pPr>
-            <a:r>
-              <a:rPr lang="en-US" sz="2200" b="0" i="0" dirty="0">
-                <a:solidFill>
-                  <a:srgbClr val="1A1A2E"/>
-                </a:solidFill>
-                <a:latin typeface="Calibri"/>
-              </a:rPr>
-              <a:t>K</a:t>
-            </a:r>
-            <a:r>
-              <a:rPr sz="2200" b="0" i="0" dirty="0">
-                <a:solidFill>
-                  <a:srgbClr val="1A1A2E"/>
-                </a:solidFill>
-                <a:latin typeface="Calibri"/>
-              </a:rPr>
-              <a:t>eep your Undo key (</a:t>
-            </a:r>
-            <a:r>
-              <a:rPr sz="2200" b="0" i="0" dirty="0" err="1">
-                <a:solidFill>
-                  <a:srgbClr val="1A1A2E"/>
-                </a:solidFill>
-                <a:latin typeface="Calibri"/>
-              </a:rPr>
-              <a:t>Cmd+Z</a:t>
-            </a:r>
-            <a:r>
-              <a:rPr sz="2200" b="0" i="0" dirty="0">
-                <a:solidFill>
-                  <a:srgbClr val="1A1A2E"/>
-                </a:solidFill>
-                <a:latin typeface="Calibri"/>
-              </a:rPr>
-              <a:t> / </a:t>
-            </a:r>
-            <a:r>
-              <a:rPr sz="2200" b="0" i="0" dirty="0" err="1">
-                <a:solidFill>
-                  <a:srgbClr val="1A1A2E"/>
-                </a:solidFill>
-                <a:latin typeface="Calibri"/>
-              </a:rPr>
-              <a:t>Ctrl+Z</a:t>
-            </a:r>
-            <a:r>
-              <a:rPr sz="2200" b="0" i="0" dirty="0">
-                <a:solidFill>
-                  <a:srgbClr val="1A1A2E"/>
-                </a:solidFill>
-                <a:latin typeface="Calibri"/>
-              </a:rPr>
-              <a:t>) handy!</a:t>
-            </a:r>
-            <a:r>
-              <a:rPr lang="en-US" sz="2200" b="0" i="0" dirty="0">
-                <a:solidFill>
-                  <a:srgbClr val="1A1A2E"/>
-                </a:solidFill>
-                <a:latin typeface="Calibri"/>
-              </a:rPr>
-              <a:t> </a:t>
-            </a:r>
-            <a:r>
-              <a:rPr lang="en-US" sz="2200" dirty="0">
-                <a:solidFill>
-                  <a:srgbClr val="1A1A2E"/>
-                </a:solidFill>
-                <a:latin typeface="Calibri"/>
-                <a:sym typeface="Wingdings" pitchFamily="2" charset="2"/>
-              </a:rPr>
-              <a:t></a:t>
-            </a:r>
-            <a:endParaRPr lang="en-US" sz="2200" b="0" i="0" dirty="0">
-              <a:solidFill>
-                <a:srgbClr val="1A1A2E"/>
-              </a:solidFill>
-              <a:latin typeface="Calibri"/>
-            </a:endParaRPr>
-          </a:p>
-          <a:p>
-            <a:pPr>
-              <a:spcBef>
-                <a:spcPts val="400"/>
-              </a:spcBef>
-              <a:spcAft>
-                <a:spcPts val="200"/>
-              </a:spcAft>
-            </a:pPr>
-            <a:r>
-              <a:rPr lang="en-US" sz="2400" b="0" i="0" dirty="0">
-                <a:solidFill>
-                  <a:srgbClr val="1A1A2E"/>
-                </a:solidFill>
-                <a:latin typeface="Calibri"/>
-              </a:rPr>
-              <a:t>Early Users report great results</a:t>
-            </a:r>
-            <a:endParaRPr sz="2400" b="0" i="0" dirty="0">
-              <a:solidFill>
-                <a:srgbClr val="1A1A2E"/>
-              </a:solidFill>
-              <a:latin typeface="Calibri"/>
-            </a:endParaRPr>
+              <a:rPr sz="1500" b="0" i="0">
+                <a:solidFill>
+                  <a:srgbClr val="1A1A2E"/>
+                </a:solidFill>
+                <a:latin typeface="Calibri"/>
+              </a:rPr>
+              <a:t> — keep your Undo key (Cmd+Z / Ctrl+Z) handy!</a:t>
+            </a:r>
           </a:p>
         </p:txBody>
       </p:sp>
@@ -8275,7 +7808,7 @@
 </file>
 
 <file path=ppt/slides/slide10.xml><?xml version="1.0" encoding="utf-8"?>
-<p:sld xmlns:a="http://schemas.openxmlformats.org/drawingml/2006/main" xmlns:r="http://schemas.openxmlformats.org/officeDocument/2006/relationships" xmlns:p="http://schemas.openxmlformats.org/presentationml/2006/main">
+<p:sld xmlns:a="http://schemas.openxmlformats.org/drawingml/2006/main" xmlns:p="http://schemas.openxmlformats.org/presentationml/2006/main" xmlns:r="http://schemas.openxmlformats.org/officeDocument/2006/relationships">
   <p:cSld>
     <p:spTree>
       <p:nvGrpSpPr>
@@ -8283,14 +7816,7 @@
         <p:cNvGrpSpPr/>
         <p:nvPr/>
       </p:nvGrpSpPr>
-      <p:grpSpPr>
-        <a:xfrm>
-          <a:off x="0" y="0"/>
-          <a:ext cx="0" cy="0"/>
-          <a:chOff x="0" y="0"/>
-          <a:chExt cx="0" cy="0"/>
-        </a:xfrm>
-      </p:grpSpPr>
+      <p:grpSpPr/>
       <p:sp>
         <p:nvSpPr>
           <p:cNvPr id="2" name="Title 1"/>
@@ -8330,7 +7856,7 @@
           </a:xfrm>
         </p:spPr>
         <p:txBody>
-          <a:bodyPr wrap="square" lIns="109728" tIns="91440" rIns="109728" bIns="91440"/>
+          <a:bodyPr wrap="square" lIns="109728" rIns="109728" tIns="91440" bIns="91440"/>
           <a:lstStyle/>
           <a:p>
             <a:pPr>
@@ -8390,25 +7916,13 @@
                 <a:tableStyleId>{5C22544A-7EE6-4342-B048-85BDC9FD1C3A}</a:tableStyleId>
               </a:tblPr>
               <a:tblGrid>
-                <a:gridCol w="5623560">
-                  <a:extLst>
-                    <a:ext uri="{9D8B030D-6E8A-4147-A177-3AD203B41FA5}">
-                      <a16:colId xmlns:a16="http://schemas.microsoft.com/office/drawing/2014/main" val="20000"/>
-                    </a:ext>
-                  </a:extLst>
-                </a:gridCol>
-                <a:gridCol w="5623560">
-                  <a:extLst>
-                    <a:ext uri="{9D8B030D-6E8A-4147-A177-3AD203B41FA5}">
-                      <a16:colId xmlns:a16="http://schemas.microsoft.com/office/drawing/2014/main" val="20001"/>
-                    </a:ext>
-                  </a:extLst>
-                </a:gridCol>
+                <a:gridCol w="5623560"/>
+                <a:gridCol w="5623560"/>
               </a:tblGrid>
               <a:tr h="402336">
                 <a:tc>
                   <a:txBody>
-                    <a:bodyPr/>
+                    <a:bodyPr wrap="square"/>
                     <a:lstStyle/>
                     <a:p>
                       <a:r>
@@ -8430,7 +7944,7 @@
                 </a:tc>
                 <a:tc>
                   <a:txBody>
-                    <a:bodyPr/>
+                    <a:bodyPr wrap="square"/>
                     <a:lstStyle/>
                     <a:p>
                       <a:r>
@@ -8450,16 +7964,11 @@
                     </a:solidFill>
                   </a:tcPr>
                 </a:tc>
-                <a:extLst>
-                  <a:ext uri="{0D108BD9-81ED-4DB2-BD59-A6C34878D82A}">
-                    <a16:rowId xmlns:a16="http://schemas.microsoft.com/office/drawing/2014/main" val="10000"/>
-                  </a:ext>
-                </a:extLst>
               </a:tr>
               <a:tr h="402336">
                 <a:tc>
                   <a:txBody>
-                    <a:bodyPr/>
+                    <a:bodyPr wrap="square"/>
                     <a:lstStyle/>
                     <a:p>
                       <a:r>
@@ -8477,7 +7986,7 @@
                 </a:tc>
                 <a:tc>
                   <a:txBody>
-                    <a:bodyPr/>
+                    <a:bodyPr wrap="square"/>
                     <a:lstStyle/>
                     <a:p>
                       <a:r>
@@ -8493,16 +8002,11 @@
                   </a:txBody>
                   <a:tcPr/>
                 </a:tc>
-                <a:extLst>
-                  <a:ext uri="{0D108BD9-81ED-4DB2-BD59-A6C34878D82A}">
-                    <a16:rowId xmlns:a16="http://schemas.microsoft.com/office/drawing/2014/main" val="10001"/>
-                  </a:ext>
-                </a:extLst>
               </a:tr>
               <a:tr h="402336">
                 <a:tc>
                   <a:txBody>
-                    <a:bodyPr/>
+                    <a:bodyPr wrap="square"/>
                     <a:lstStyle/>
                     <a:p>
                       <a:r>
@@ -8524,7 +8028,7 @@
                 </a:tc>
                 <a:tc>
                   <a:txBody>
-                    <a:bodyPr/>
+                    <a:bodyPr wrap="square"/>
                     <a:lstStyle/>
                     <a:p>
                       <a:r>
@@ -8544,11 +8048,6 @@
                     </a:solidFill>
                   </a:tcPr>
                 </a:tc>
-                <a:extLst>
-                  <a:ext uri="{0D108BD9-81ED-4DB2-BD59-A6C34878D82A}">
-                    <a16:rowId xmlns:a16="http://schemas.microsoft.com/office/drawing/2014/main" val="10002"/>
-                  </a:ext>
-                </a:extLst>
               </a:tr>
             </a:tbl>
           </a:graphicData>
@@ -8769,7 +8268,7 @@
 </file>
 
 <file path=ppt/slides/slide11.xml><?xml version="1.0" encoding="utf-8"?>
-<p:sld xmlns:a="http://schemas.openxmlformats.org/drawingml/2006/main" xmlns:r="http://schemas.openxmlformats.org/officeDocument/2006/relationships" xmlns:p="http://schemas.openxmlformats.org/presentationml/2006/main">
+<p:sld xmlns:a="http://schemas.openxmlformats.org/drawingml/2006/main" xmlns:p="http://schemas.openxmlformats.org/presentationml/2006/main" xmlns:r="http://schemas.openxmlformats.org/officeDocument/2006/relationships">
   <p:cSld>
     <p:spTree>
       <p:nvGrpSpPr>
@@ -8777,14 +8276,7 @@
         <p:cNvGrpSpPr/>
         <p:nvPr/>
       </p:nvGrpSpPr>
-      <p:grpSpPr>
-        <a:xfrm>
-          <a:off x="0" y="0"/>
-          <a:ext cx="0" cy="0"/>
-          <a:chOff x="0" y="0"/>
-          <a:chExt cx="0" cy="0"/>
-        </a:xfrm>
-      </p:grpSpPr>
+      <p:grpSpPr/>
       <p:sp>
         <p:nvSpPr>
           <p:cNvPr id="2" name="Title 1"/>
@@ -8824,7 +8316,7 @@
           </a:xfrm>
         </p:spPr>
         <p:txBody>
-          <a:bodyPr wrap="square" lIns="109728" tIns="91440" rIns="109728" bIns="91440"/>
+          <a:bodyPr wrap="square" lIns="109728" rIns="109728" tIns="91440" bIns="91440"/>
           <a:lstStyle/>
           <a:p>
             <a:pPr>
@@ -8866,32 +8358,14 @@
                 <a:tableStyleId>{5C22544A-7EE6-4342-B048-85BDC9FD1C3A}</a:tableStyleId>
               </a:tblPr>
               <a:tblGrid>
-                <a:gridCol w="3749040">
-                  <a:extLst>
-                    <a:ext uri="{9D8B030D-6E8A-4147-A177-3AD203B41FA5}">
-                      <a16:colId xmlns:a16="http://schemas.microsoft.com/office/drawing/2014/main" val="20000"/>
-                    </a:ext>
-                  </a:extLst>
-                </a:gridCol>
-                <a:gridCol w="3749040">
-                  <a:extLst>
-                    <a:ext uri="{9D8B030D-6E8A-4147-A177-3AD203B41FA5}">
-                      <a16:colId xmlns:a16="http://schemas.microsoft.com/office/drawing/2014/main" val="20001"/>
-                    </a:ext>
-                  </a:extLst>
-                </a:gridCol>
-                <a:gridCol w="3749040">
-                  <a:extLst>
-                    <a:ext uri="{9D8B030D-6E8A-4147-A177-3AD203B41FA5}">
-                      <a16:colId xmlns:a16="http://schemas.microsoft.com/office/drawing/2014/main" val="20002"/>
-                    </a:ext>
-                  </a:extLst>
-                </a:gridCol>
+                <a:gridCol w="3749040"/>
+                <a:gridCol w="3749040"/>
+                <a:gridCol w="3749040"/>
               </a:tblGrid>
               <a:tr h="402336">
                 <a:tc>
                   <a:txBody>
-                    <a:bodyPr/>
+                    <a:bodyPr wrap="square"/>
                     <a:lstStyle/>
                     <a:p>
                       <a:r>
@@ -8913,7 +8387,7 @@
                 </a:tc>
                 <a:tc>
                   <a:txBody>
-                    <a:bodyPr/>
+                    <a:bodyPr wrap="square"/>
                     <a:lstStyle/>
                     <a:p>
                       <a:r>
@@ -8935,7 +8409,7 @@
                 </a:tc>
                 <a:tc>
                   <a:txBody>
-                    <a:bodyPr/>
+                    <a:bodyPr wrap="square"/>
                     <a:lstStyle/>
                     <a:p>
                       <a:r>
@@ -8955,16 +8429,11 @@
                     </a:solidFill>
                   </a:tcPr>
                 </a:tc>
-                <a:extLst>
-                  <a:ext uri="{0D108BD9-81ED-4DB2-BD59-A6C34878D82A}">
-                    <a16:rowId xmlns:a16="http://schemas.microsoft.com/office/drawing/2014/main" val="10000"/>
-                  </a:ext>
-                </a:extLst>
               </a:tr>
               <a:tr h="402336">
                 <a:tc>
                   <a:txBody>
-                    <a:bodyPr/>
+                    <a:bodyPr wrap="square"/>
                     <a:lstStyle/>
                     <a:p>
                       <a:r>
@@ -8982,7 +8451,7 @@
                 </a:tc>
                 <a:tc>
                   <a:txBody>
-                    <a:bodyPr/>
+                    <a:bodyPr wrap="square"/>
                     <a:lstStyle/>
                     <a:p>
                       <a:r>
@@ -9000,7 +8469,7 @@
                 </a:tc>
                 <a:tc>
                   <a:txBody>
-                    <a:bodyPr/>
+                    <a:bodyPr wrap="square"/>
                     <a:lstStyle/>
                     <a:p>
                       <a:r>
@@ -9016,16 +8485,11 @@
                   </a:txBody>
                   <a:tcPr/>
                 </a:tc>
-                <a:extLst>
-                  <a:ext uri="{0D108BD9-81ED-4DB2-BD59-A6C34878D82A}">
-                    <a16:rowId xmlns:a16="http://schemas.microsoft.com/office/drawing/2014/main" val="10001"/>
-                  </a:ext>
-                </a:extLst>
               </a:tr>
               <a:tr h="402336">
                 <a:tc>
                   <a:txBody>
-                    <a:bodyPr/>
+                    <a:bodyPr wrap="square"/>
                     <a:lstStyle/>
                     <a:p>
                       <a:r>
@@ -9047,7 +8511,7 @@
                 </a:tc>
                 <a:tc>
                   <a:txBody>
-                    <a:bodyPr/>
+                    <a:bodyPr wrap="square"/>
                     <a:lstStyle/>
                     <a:p>
                       <a:r>
@@ -9069,7 +8533,7 @@
                 </a:tc>
                 <a:tc>
                   <a:txBody>
-                    <a:bodyPr/>
+                    <a:bodyPr wrap="square"/>
                     <a:lstStyle/>
                     <a:p>
                       <a:r>
@@ -9089,16 +8553,11 @@
                     </a:solidFill>
                   </a:tcPr>
                 </a:tc>
-                <a:extLst>
-                  <a:ext uri="{0D108BD9-81ED-4DB2-BD59-A6C34878D82A}">
-                    <a16:rowId xmlns:a16="http://schemas.microsoft.com/office/drawing/2014/main" val="10002"/>
-                  </a:ext>
-                </a:extLst>
               </a:tr>
               <a:tr h="402336">
                 <a:tc>
                   <a:txBody>
-                    <a:bodyPr/>
+                    <a:bodyPr wrap="square"/>
                     <a:lstStyle/>
                     <a:p>
                       <a:r>
@@ -9116,7 +8575,7 @@
                 </a:tc>
                 <a:tc>
                   <a:txBody>
-                    <a:bodyPr/>
+                    <a:bodyPr wrap="square"/>
                     <a:lstStyle/>
                     <a:p>
                       <a:r>
@@ -9134,7 +8593,7 @@
                 </a:tc>
                 <a:tc>
                   <a:txBody>
-                    <a:bodyPr/>
+                    <a:bodyPr wrap="square"/>
                     <a:lstStyle/>
                     <a:p>
                       <a:r>
@@ -9150,16 +8609,11 @@
                   </a:txBody>
                   <a:tcPr/>
                 </a:tc>
-                <a:extLst>
-                  <a:ext uri="{0D108BD9-81ED-4DB2-BD59-A6C34878D82A}">
-                    <a16:rowId xmlns:a16="http://schemas.microsoft.com/office/drawing/2014/main" val="10003"/>
-                  </a:ext>
-                </a:extLst>
               </a:tr>
               <a:tr h="402336">
                 <a:tc>
                   <a:txBody>
-                    <a:bodyPr/>
+                    <a:bodyPr wrap="square"/>
                     <a:lstStyle/>
                     <a:p>
                       <a:r>
@@ -9181,7 +8635,7 @@
                 </a:tc>
                 <a:tc>
                   <a:txBody>
-                    <a:bodyPr/>
+                    <a:bodyPr wrap="square"/>
                     <a:lstStyle/>
                     <a:p>
                       <a:r>
@@ -9203,7 +8657,7 @@
                 </a:tc>
                 <a:tc>
                   <a:txBody>
-                    <a:bodyPr/>
+                    <a:bodyPr wrap="square"/>
                     <a:lstStyle/>
                     <a:p>
                       <a:r>
@@ -9223,16 +8677,11 @@
                     </a:solidFill>
                   </a:tcPr>
                 </a:tc>
-                <a:extLst>
-                  <a:ext uri="{0D108BD9-81ED-4DB2-BD59-A6C34878D82A}">
-                    <a16:rowId xmlns:a16="http://schemas.microsoft.com/office/drawing/2014/main" val="10004"/>
-                  </a:ext>
-                </a:extLst>
               </a:tr>
               <a:tr h="402336">
                 <a:tc>
                   <a:txBody>
-                    <a:bodyPr/>
+                    <a:bodyPr wrap="square"/>
                     <a:lstStyle/>
                     <a:p>
                       <a:r>
@@ -9250,7 +8699,7 @@
                 </a:tc>
                 <a:tc>
                   <a:txBody>
-                    <a:bodyPr/>
+                    <a:bodyPr wrap="square"/>
                     <a:lstStyle/>
                     <a:p>
                       <a:r>
@@ -9268,7 +8717,7 @@
                 </a:tc>
                 <a:tc>
                   <a:txBody>
-                    <a:bodyPr/>
+                    <a:bodyPr wrap="square"/>
                     <a:lstStyle/>
                     <a:p>
                       <a:r>
@@ -9284,16 +8733,11 @@
                   </a:txBody>
                   <a:tcPr/>
                 </a:tc>
-                <a:extLst>
-                  <a:ext uri="{0D108BD9-81ED-4DB2-BD59-A6C34878D82A}">
-                    <a16:rowId xmlns:a16="http://schemas.microsoft.com/office/drawing/2014/main" val="10005"/>
-                  </a:ext>
-                </a:extLst>
               </a:tr>
               <a:tr h="402336">
                 <a:tc>
                   <a:txBody>
-                    <a:bodyPr/>
+                    <a:bodyPr wrap="square"/>
                     <a:lstStyle/>
                     <a:p>
                       <a:r>
@@ -9315,7 +8759,7 @@
                 </a:tc>
                 <a:tc>
                   <a:txBody>
-                    <a:bodyPr/>
+                    <a:bodyPr wrap="square"/>
                     <a:lstStyle/>
                     <a:p>
                       <a:r>
@@ -9337,7 +8781,7 @@
                 </a:tc>
                 <a:tc>
                   <a:txBody>
-                    <a:bodyPr/>
+                    <a:bodyPr wrap="square"/>
                     <a:lstStyle/>
                     <a:p>
                       <a:r>
@@ -9357,11 +8801,6 @@
                     </a:solidFill>
                   </a:tcPr>
                 </a:tc>
-                <a:extLst>
-                  <a:ext uri="{0D108BD9-81ED-4DB2-BD59-A6C34878D82A}">
-                    <a16:rowId xmlns:a16="http://schemas.microsoft.com/office/drawing/2014/main" val="10006"/>
-                  </a:ext>
-                </a:extLst>
               </a:tr>
             </a:tbl>
           </a:graphicData>
@@ -9376,7 +8815,7 @@
 </file>
 
 <file path=ppt/slides/slide12.xml><?xml version="1.0" encoding="utf-8"?>
-<p:sld xmlns:a="http://schemas.openxmlformats.org/drawingml/2006/main" xmlns:r="http://schemas.openxmlformats.org/officeDocument/2006/relationships" xmlns:p="http://schemas.openxmlformats.org/presentationml/2006/main">
+<p:sld xmlns:a="http://schemas.openxmlformats.org/drawingml/2006/main" xmlns:p="http://schemas.openxmlformats.org/presentationml/2006/main" xmlns:r="http://schemas.openxmlformats.org/officeDocument/2006/relationships">
   <p:cSld>
     <p:spTree>
       <p:nvGrpSpPr>
@@ -9384,14 +8823,7 @@
         <p:cNvGrpSpPr/>
         <p:nvPr/>
       </p:nvGrpSpPr>
-      <p:grpSpPr>
-        <a:xfrm>
-          <a:off x="0" y="0"/>
-          <a:ext cx="0" cy="0"/>
-          <a:chOff x="0" y="0"/>
-          <a:chExt cx="0" cy="0"/>
-        </a:xfrm>
-      </p:grpSpPr>
+      <p:grpSpPr/>
       <p:sp>
         <p:nvSpPr>
           <p:cNvPr id="2" name="Title 1"/>
@@ -9431,7 +8863,7 @@
           </a:xfrm>
         </p:spPr>
         <p:txBody>
-          <a:bodyPr wrap="square" lIns="109728" tIns="91440" rIns="109728" bIns="91440"/>
+          <a:bodyPr wrap="square" lIns="109728" rIns="109728" tIns="91440" bIns="91440"/>
           <a:lstStyle/>
           <a:p>
             <a:pPr>
@@ -9705,7 +9137,7 @@
 </file>
 
 <file path=ppt/slides/slide13.xml><?xml version="1.0" encoding="utf-8"?>
-<p:sld xmlns:a="http://schemas.openxmlformats.org/drawingml/2006/main" xmlns:r="http://schemas.openxmlformats.org/officeDocument/2006/relationships" xmlns:p="http://schemas.openxmlformats.org/presentationml/2006/main">
+<p:sld xmlns:a="http://schemas.openxmlformats.org/drawingml/2006/main" xmlns:p="http://schemas.openxmlformats.org/presentationml/2006/main" xmlns:r="http://schemas.openxmlformats.org/officeDocument/2006/relationships">
   <p:cSld>
     <p:spTree>
       <p:nvGrpSpPr>
@@ -9713,14 +9145,7 @@
         <p:cNvGrpSpPr/>
         <p:nvPr/>
       </p:nvGrpSpPr>
-      <p:grpSpPr>
-        <a:xfrm>
-          <a:off x="0" y="0"/>
-          <a:ext cx="0" cy="0"/>
-          <a:chOff x="0" y="0"/>
-          <a:chExt cx="0" cy="0"/>
-        </a:xfrm>
-      </p:grpSpPr>
+      <p:grpSpPr/>
       <p:sp>
         <p:nvSpPr>
           <p:cNvPr id="2" name="Title 1"/>
@@ -9760,7 +9185,7 @@
           </a:xfrm>
         </p:spPr>
         <p:txBody>
-          <a:bodyPr wrap="square" lIns="109728" tIns="91440" rIns="109728" bIns="91440"/>
+          <a:bodyPr wrap="square" lIns="109728" rIns="109728" tIns="91440" bIns="91440"/>
           <a:lstStyle/>
           <a:p>
             <a:pPr>
@@ -9922,7 +9347,7 @@
 </file>
 
 <file path=ppt/slides/slide14.xml><?xml version="1.0" encoding="utf-8"?>
-<p:sld xmlns:a="http://schemas.openxmlformats.org/drawingml/2006/main" xmlns:r="http://schemas.openxmlformats.org/officeDocument/2006/relationships" xmlns:p="http://schemas.openxmlformats.org/presentationml/2006/main">
+<p:sld xmlns:a="http://schemas.openxmlformats.org/drawingml/2006/main" xmlns:p="http://schemas.openxmlformats.org/presentationml/2006/main" xmlns:r="http://schemas.openxmlformats.org/officeDocument/2006/relationships">
   <p:cSld>
     <p:spTree>
       <p:nvGrpSpPr>
@@ -9930,14 +9355,7 @@
         <p:cNvGrpSpPr/>
         <p:nvPr/>
       </p:nvGrpSpPr>
-      <p:grpSpPr>
-        <a:xfrm>
-          <a:off x="0" y="0"/>
-          <a:ext cx="0" cy="0"/>
-          <a:chOff x="0" y="0"/>
-          <a:chExt cx="0" cy="0"/>
-        </a:xfrm>
-      </p:grpSpPr>
+      <p:grpSpPr/>
       <p:sp>
         <p:nvSpPr>
           <p:cNvPr id="2" name="Title 1"/>
@@ -9977,7 +9395,7 @@
           </a:xfrm>
         </p:spPr>
         <p:txBody>
-          <a:bodyPr wrap="square" lIns="109728" tIns="91440" rIns="109728" bIns="91440"/>
+          <a:bodyPr wrap="square" lIns="109728" rIns="109728" tIns="91440" bIns="91440"/>
           <a:lstStyle/>
           <a:p>
             <a:pPr>
@@ -10037,7 +9455,7 @@
           </a:solidFill>
         </p:spPr>
         <p:txBody>
-          <a:bodyPr wrap="none" lIns="146304" tIns="128016" rIns="109728" bIns="109728">
+          <a:bodyPr wrap="none" lIns="146304" rIns="109728" tIns="128016" bIns="109728">
             <a:spAutoFit/>
           </a:bodyPr>
           <a:lstStyle/>
@@ -10299,7 +9717,7 @@
 </file>
 
 <file path=ppt/slides/slide15.xml><?xml version="1.0" encoding="utf-8"?>
-<p:sld xmlns:a="http://schemas.openxmlformats.org/drawingml/2006/main" xmlns:r="http://schemas.openxmlformats.org/officeDocument/2006/relationships" xmlns:p="http://schemas.openxmlformats.org/presentationml/2006/main">
+<p:sld xmlns:a="http://schemas.openxmlformats.org/drawingml/2006/main" xmlns:p="http://schemas.openxmlformats.org/presentationml/2006/main" xmlns:r="http://schemas.openxmlformats.org/officeDocument/2006/relationships">
   <p:cSld>
     <p:spTree>
       <p:nvGrpSpPr>
@@ -10307,14 +9725,7 @@
         <p:cNvGrpSpPr/>
         <p:nvPr/>
       </p:nvGrpSpPr>
-      <p:grpSpPr>
-        <a:xfrm>
-          <a:off x="0" y="0"/>
-          <a:ext cx="0" cy="0"/>
-          <a:chOff x="0" y="0"/>
-          <a:chExt cx="0" cy="0"/>
-        </a:xfrm>
-      </p:grpSpPr>
+      <p:grpSpPr/>
       <p:sp>
         <p:nvSpPr>
           <p:cNvPr id="2" name="Title 1"/>
@@ -10354,7 +9765,7 @@
           </a:xfrm>
         </p:spPr>
         <p:txBody>
-          <a:bodyPr wrap="square" lIns="109728" tIns="91440" rIns="109728" bIns="91440"/>
+          <a:bodyPr wrap="square" lIns="109728" rIns="109728" tIns="91440" bIns="91440"/>
           <a:lstStyle/>
           <a:p>
             <a:pPr>
@@ -10655,7 +10066,7 @@
 </file>
 
 <file path=ppt/slides/slide16.xml><?xml version="1.0" encoding="utf-8"?>
-<p:sld xmlns:a="http://schemas.openxmlformats.org/drawingml/2006/main" xmlns:r="http://schemas.openxmlformats.org/officeDocument/2006/relationships" xmlns:p="http://schemas.openxmlformats.org/presentationml/2006/main">
+<p:sld xmlns:a="http://schemas.openxmlformats.org/drawingml/2006/main" xmlns:p="http://schemas.openxmlformats.org/presentationml/2006/main" xmlns:r="http://schemas.openxmlformats.org/officeDocument/2006/relationships">
   <p:cSld>
     <p:spTree>
       <p:nvGrpSpPr>
@@ -10663,14 +10074,7 @@
         <p:cNvGrpSpPr/>
         <p:nvPr/>
       </p:nvGrpSpPr>
-      <p:grpSpPr>
-        <a:xfrm>
-          <a:off x="0" y="0"/>
-          <a:ext cx="0" cy="0"/>
-          <a:chOff x="0" y="0"/>
-          <a:chExt cx="0" cy="0"/>
-        </a:xfrm>
-      </p:grpSpPr>
+      <p:grpSpPr/>
       <p:sp>
         <p:nvSpPr>
           <p:cNvPr id="2" name="Title 1"/>
@@ -10710,7 +10114,7 @@
           </a:xfrm>
         </p:spPr>
         <p:txBody>
-          <a:bodyPr wrap="square" lIns="109728" tIns="91440" rIns="109728" bIns="91440"/>
+          <a:bodyPr wrap="square" lIns="109728" rIns="109728" tIns="91440" bIns="91440"/>
           <a:lstStyle/>
           <a:p>
             <a:pPr>
@@ -10956,7 +10360,7 @@
 </file>
 
 <file path=ppt/slides/slide17.xml><?xml version="1.0" encoding="utf-8"?>
-<p:sld xmlns:a="http://schemas.openxmlformats.org/drawingml/2006/main" xmlns:r="http://schemas.openxmlformats.org/officeDocument/2006/relationships" xmlns:p="http://schemas.openxmlformats.org/presentationml/2006/main">
+<p:sld xmlns:a="http://schemas.openxmlformats.org/drawingml/2006/main" xmlns:p="http://schemas.openxmlformats.org/presentationml/2006/main" xmlns:r="http://schemas.openxmlformats.org/officeDocument/2006/relationships">
   <p:cSld>
     <p:spTree>
       <p:nvGrpSpPr>
@@ -10964,14 +10368,7 @@
         <p:cNvGrpSpPr/>
         <p:nvPr/>
       </p:nvGrpSpPr>
-      <p:grpSpPr>
-        <a:xfrm>
-          <a:off x="0" y="0"/>
-          <a:ext cx="0" cy="0"/>
-          <a:chOff x="0" y="0"/>
-          <a:chExt cx="0" cy="0"/>
-        </a:xfrm>
-      </p:grpSpPr>
+      <p:grpSpPr/>
       <p:sp>
         <p:nvSpPr>
           <p:cNvPr id="2" name="Title 1"/>
@@ -11011,7 +10408,7 @@
           </a:xfrm>
         </p:spPr>
         <p:txBody>
-          <a:bodyPr wrap="square" lIns="109728" tIns="91440" rIns="109728" bIns="91440"/>
+          <a:bodyPr wrap="square" lIns="109728" rIns="109728" tIns="91440" bIns="91440"/>
           <a:lstStyle/>
           <a:p>
             <a:pPr>
@@ -11295,7 +10692,7 @@
 </file>
 
 <file path=ppt/slides/slide2.xml><?xml version="1.0" encoding="utf-8"?>
-<p:sld xmlns:a="http://schemas.openxmlformats.org/drawingml/2006/main" xmlns:r="http://schemas.openxmlformats.org/officeDocument/2006/relationships" xmlns:p="http://schemas.openxmlformats.org/presentationml/2006/main">
+<p:sld xmlns:a="http://schemas.openxmlformats.org/drawingml/2006/main" xmlns:p="http://schemas.openxmlformats.org/presentationml/2006/main" xmlns:r="http://schemas.openxmlformats.org/officeDocument/2006/relationships">
   <p:cSld>
     <p:spTree>
       <p:nvGrpSpPr>
@@ -11303,14 +10700,7 @@
         <p:cNvGrpSpPr/>
         <p:nvPr/>
       </p:nvGrpSpPr>
-      <p:grpSpPr>
-        <a:xfrm>
-          <a:off x="0" y="0"/>
-          <a:ext cx="0" cy="0"/>
-          <a:chOff x="0" y="0"/>
-          <a:chExt cx="0" cy="0"/>
-        </a:xfrm>
-      </p:grpSpPr>
+      <p:grpSpPr/>
       <p:sp>
         <p:nvSpPr>
           <p:cNvPr id="2" name="Title 1"/>
@@ -11350,9 +10740,7 @@
           </a:xfrm>
         </p:spPr>
         <p:txBody>
-          <a:bodyPr wrap="square" lIns="109728" tIns="91440" rIns="109728" bIns="91440">
-            <a:normAutofit/>
-          </a:bodyPr>
+          <a:bodyPr wrap="square" lIns="109728" rIns="109728" tIns="91440" bIns="91440"/>
           <a:lstStyle/>
           <a:p>
             <a:pPr>
@@ -11364,7 +10752,7 @@
               </a:spcAft>
             </a:pPr>
             <a:r>
-              <a:rPr sz="2400" b="0" i="0" dirty="0">
+              <a:rPr sz="1500" b="0" i="0">
                 <a:solidFill>
                   <a:srgbClr val="1A1A2E"/>
                 </a:solidFill>
@@ -11373,7 +10761,7 @@
               <a:t>IBM i's 5250 green-screen has always had an </a:t>
             </a:r>
             <a:r>
-              <a:rPr sz="2400" b="1" i="0" dirty="0">
+              <a:rPr sz="1500" b="1" i="0">
                 <a:solidFill>
                   <a:srgbClr val="1F497D"/>
                 </a:solidFill>
@@ -11382,7 +10770,7 @@
               <a:t>F4 key</a:t>
             </a:r>
             <a:r>
-              <a:rPr sz="2400" b="0" i="0" dirty="0">
+              <a:rPr sz="1500" b="0" i="0">
                 <a:solidFill>
                   <a:srgbClr val="1A1A2E"/>
                 </a:solidFill>
@@ -11390,15 +10778,9 @@
               </a:rPr>
               <a:t> for command prompting</a:t>
             </a:r>
-            <a:endParaRPr lang="en-US" sz="2400" b="0" i="0" dirty="0">
-              <a:solidFill>
-                <a:srgbClr val="1A1A2E"/>
-              </a:solidFill>
-              <a:latin typeface="Calibri"/>
-            </a:endParaRPr>
-          </a:p>
-          <a:p>
-            <a:pPr lvl="1">
+          </a:p>
+          <a:p>
+            <a:pPr>
               <a:spcBef>
                 <a:spcPts val="200"/>
               </a:spcBef>
@@ -11407,29 +10789,14 @@
               </a:spcAft>
             </a:pPr>
             <a:r>
-              <a:rPr lang="en-US" sz="2200" dirty="0">
-                <a:solidFill>
-                  <a:srgbClr val="1A1A2E"/>
-                </a:solidFill>
-                <a:latin typeface="Calibri"/>
-              </a:rPr>
-              <a:t>Originated way back on System/38 </a:t>
-            </a:r>
-            <a:r>
-              <a:rPr lang="en-US" sz="2200">
-                <a:solidFill>
-                  <a:srgbClr val="1A1A2E"/>
-                </a:solidFill>
-                <a:latin typeface="Calibri"/>
-              </a:rPr>
-              <a:t>CPF release 1.0 circa 1980</a:t>
-            </a:r>
-            <a:endParaRPr sz="2200" b="0" i="0" dirty="0">
-              <a:solidFill>
-                <a:srgbClr val="1A1A2E"/>
-              </a:solidFill>
-              <a:latin typeface="Calibri"/>
-            </a:endParaRPr>
+              <a:rPr sz="1500" b="0" i="0">
+                <a:solidFill>
+                  <a:srgbClr val="1A1A2E"/>
+                </a:solidFill>
+                <a:latin typeface="Calibri"/>
+              </a:rPr>
+              <a:t>Pressing F4 on a CL command opens a full-screen parameter fill-in form</a:t>
+            </a:r>
           </a:p>
           <a:p>
             <a:pPr>
@@ -11441,13 +10808,13 @@
               </a:spcAft>
             </a:pPr>
             <a:r>
-              <a:rPr sz="2400" b="0" i="0" dirty="0">
-                <a:solidFill>
-                  <a:srgbClr val="1A1A2E"/>
-                </a:solidFill>
-                <a:latin typeface="Calibri"/>
-              </a:rPr>
-              <a:t>Pressing F4 on a CL command opens a full-screen parameter fill-in form</a:t>
+              <a:rPr sz="1500" b="0" i="0">
+                <a:solidFill>
+                  <a:srgbClr val="1A1A2E"/>
+                </a:solidFill>
+                <a:latin typeface="Calibri"/>
+              </a:rPr>
+              <a:t>Each parameter is labeled, described, and validated with allowed values</a:t>
             </a:r>
           </a:p>
           <a:p>
@@ -11460,13 +10827,13 @@
               </a:spcAft>
             </a:pPr>
             <a:r>
-              <a:rPr sz="2400" b="0" i="0" dirty="0">
-                <a:solidFill>
-                  <a:srgbClr val="1A1A2E"/>
-                </a:solidFill>
-                <a:latin typeface="Calibri"/>
-              </a:rPr>
-              <a:t>Each parameter is labeled, described, and validated with allowed values</a:t>
+              <a:rPr sz="1500" b="0" i="0">
+                <a:solidFill>
+                  <a:srgbClr val="1A1A2E"/>
+                </a:solidFill>
+                <a:latin typeface="Calibri"/>
+              </a:rPr>
+              <a:t>Developers have relied on it for 40 years to build CL programs correctly</a:t>
             </a:r>
           </a:p>
           <a:p>
@@ -11479,41 +10846,13 @@
               </a:spcAft>
             </a:pPr>
             <a:r>
-              <a:rPr sz="2400" b="0" i="0" dirty="0">
-                <a:solidFill>
-                  <a:srgbClr val="1A1A2E"/>
-                </a:solidFill>
-                <a:latin typeface="Calibri"/>
-              </a:rPr>
-              <a:t>Developers have relied on it for 40 years to build CL programs correctly</a:t>
-            </a:r>
-          </a:p>
-          <a:p>
-            <a:pPr>
-              <a:spcBef>
-                <a:spcPts val="200"/>
-              </a:spcBef>
-              <a:spcAft>
-                <a:spcPts val="200"/>
-              </a:spcAft>
-            </a:pPr>
-            <a:r>
-              <a:rPr sz="2400" b="0" i="0" dirty="0" err="1">
-                <a:solidFill>
-                  <a:srgbClr val="1A1A2E"/>
-                </a:solidFill>
-                <a:latin typeface="Calibri"/>
-              </a:rPr>
-              <a:t>CLPrompter</a:t>
-            </a:r>
-            <a:r>
-              <a:rPr sz="2400" b="0" i="0" dirty="0">
-                <a:solidFill>
-                  <a:srgbClr val="1A1A2E"/>
-                </a:solidFill>
-                <a:latin typeface="Calibri"/>
-              </a:rPr>
-              <a:t> recreates this experience natively inside VS Code</a:t>
+              <a:rPr sz="1500" b="0" i="0">
+                <a:solidFill>
+                  <a:srgbClr val="1A1A2E"/>
+                </a:solidFill>
+                <a:latin typeface="Calibri"/>
+              </a:rPr>
+              <a:t>CLPrompter recreates this experience natively inside VS Code</a:t>
             </a:r>
           </a:p>
         </p:txBody>
@@ -11527,7 +10866,7 @@
 </file>
 
 <file path=ppt/slides/slide3.xml><?xml version="1.0" encoding="utf-8"?>
-<p:sld xmlns:a="http://schemas.openxmlformats.org/drawingml/2006/main" xmlns:r="http://schemas.openxmlformats.org/officeDocument/2006/relationships" xmlns:p="http://schemas.openxmlformats.org/presentationml/2006/main">
+<p:sld xmlns:a="http://schemas.openxmlformats.org/drawingml/2006/main" xmlns:p="http://schemas.openxmlformats.org/presentationml/2006/main" xmlns:r="http://schemas.openxmlformats.org/officeDocument/2006/relationships">
   <p:cSld>
     <p:spTree>
       <p:nvGrpSpPr>
@@ -11535,14 +10874,7 @@
         <p:cNvGrpSpPr/>
         <p:nvPr/>
       </p:nvGrpSpPr>
-      <p:grpSpPr>
-        <a:xfrm>
-          <a:off x="0" y="0"/>
-          <a:ext cx="0" cy="0"/>
-          <a:chOff x="0" y="0"/>
-          <a:chExt cx="0" cy="0"/>
-        </a:xfrm>
-      </p:grpSpPr>
+      <p:grpSpPr/>
       <p:sp>
         <p:nvSpPr>
           <p:cNvPr id="2" name="Title 1"/>
@@ -11582,7 +10914,7 @@
           </a:xfrm>
         </p:spPr>
         <p:txBody>
-          <a:bodyPr wrap="square" lIns="109728" tIns="91440" rIns="109728" bIns="91440"/>
+          <a:bodyPr wrap="square" lIns="109728" rIns="109728" tIns="91440" bIns="91440"/>
           <a:lstStyle/>
           <a:p>
             <a:pPr>
@@ -11853,7 +11185,7 @@
 </file>
 
 <file path=ppt/slides/slide4.xml><?xml version="1.0" encoding="utf-8"?>
-<p:sld xmlns:a="http://schemas.openxmlformats.org/drawingml/2006/main" xmlns:r="http://schemas.openxmlformats.org/officeDocument/2006/relationships" xmlns:p="http://schemas.openxmlformats.org/presentationml/2006/main">
+<p:sld xmlns:a="http://schemas.openxmlformats.org/drawingml/2006/main" xmlns:p="http://schemas.openxmlformats.org/presentationml/2006/main" xmlns:r="http://schemas.openxmlformats.org/officeDocument/2006/relationships">
   <p:cSld>
     <p:spTree>
       <p:nvGrpSpPr>
@@ -11861,14 +11193,7 @@
         <p:cNvGrpSpPr/>
         <p:nvPr/>
       </p:nvGrpSpPr>
-      <p:grpSpPr>
-        <a:xfrm>
-          <a:off x="0" y="0"/>
-          <a:ext cx="0" cy="0"/>
-          <a:chOff x="0" y="0"/>
-          <a:chExt cx="0" cy="0"/>
-        </a:xfrm>
-      </p:grpSpPr>
+      <p:grpSpPr/>
       <p:sp>
         <p:nvSpPr>
           <p:cNvPr id="2" name="Title 1"/>
@@ -11908,7 +11233,7 @@
           </a:xfrm>
         </p:spPr>
         <p:txBody>
-          <a:bodyPr wrap="square" lIns="109728" tIns="91440" rIns="109728" bIns="91440"/>
+          <a:bodyPr wrap="square" lIns="109728" rIns="109728" tIns="91440" bIns="91440"/>
           <a:lstStyle/>
           <a:p>
             <a:pPr>
@@ -12199,7 +11524,7 @@
 </file>
 
 <file path=ppt/slides/slide5.xml><?xml version="1.0" encoding="utf-8"?>
-<p:sld xmlns:a="http://schemas.openxmlformats.org/drawingml/2006/main" xmlns:r="http://schemas.openxmlformats.org/officeDocument/2006/relationships" xmlns:p="http://schemas.openxmlformats.org/presentationml/2006/main">
+<p:sld xmlns:a="http://schemas.openxmlformats.org/drawingml/2006/main" xmlns:p="http://schemas.openxmlformats.org/presentationml/2006/main" xmlns:r="http://schemas.openxmlformats.org/officeDocument/2006/relationships">
   <p:cSld>
     <p:spTree>
       <p:nvGrpSpPr>
@@ -12207,14 +11532,7 @@
         <p:cNvGrpSpPr/>
         <p:nvPr/>
       </p:nvGrpSpPr>
-      <p:grpSpPr>
-        <a:xfrm>
-          <a:off x="0" y="0"/>
-          <a:ext cx="0" cy="0"/>
-          <a:chOff x="0" y="0"/>
-          <a:chExt cx="0" cy="0"/>
-        </a:xfrm>
-      </p:grpSpPr>
+      <p:grpSpPr/>
       <p:sp>
         <p:nvSpPr>
           <p:cNvPr id="2" name="Title 1"/>
@@ -12254,7 +11572,7 @@
           </a:xfrm>
         </p:spPr>
         <p:txBody>
-          <a:bodyPr wrap="square" lIns="109728" tIns="91440" rIns="109728" bIns="91440"/>
+          <a:bodyPr wrap="square" lIns="109728" rIns="109728" tIns="91440" bIns="91440"/>
           <a:lstStyle/>
           <a:p>
             <a:pPr>
@@ -12389,7 +11707,7 @@
 </file>
 
 <file path=ppt/slides/slide6.xml><?xml version="1.0" encoding="utf-8"?>
-<p:sld xmlns:a="http://schemas.openxmlformats.org/drawingml/2006/main" xmlns:r="http://schemas.openxmlformats.org/officeDocument/2006/relationships" xmlns:p="http://schemas.openxmlformats.org/presentationml/2006/main">
+<p:sld xmlns:a="http://schemas.openxmlformats.org/drawingml/2006/main" xmlns:p="http://schemas.openxmlformats.org/presentationml/2006/main" xmlns:r="http://schemas.openxmlformats.org/officeDocument/2006/relationships">
   <p:cSld>
     <p:spTree>
       <p:nvGrpSpPr>
@@ -12397,14 +11715,7 @@
         <p:cNvGrpSpPr/>
         <p:nvPr/>
       </p:nvGrpSpPr>
-      <p:grpSpPr>
-        <a:xfrm>
-          <a:off x="0" y="0"/>
-          <a:ext cx="0" cy="0"/>
-          <a:chOff x="0" y="0"/>
-          <a:chExt cx="0" cy="0"/>
-        </a:xfrm>
-      </p:grpSpPr>
+      <p:grpSpPr/>
       <p:sp>
         <p:nvSpPr>
           <p:cNvPr id="2" name="Title 1"/>
@@ -12444,7 +11755,7 @@
           </a:xfrm>
         </p:spPr>
         <p:txBody>
-          <a:bodyPr wrap="square" lIns="109728" tIns="91440" rIns="109728" bIns="91440"/>
+          <a:bodyPr wrap="square" lIns="109728" rIns="109728" tIns="91440" bIns="91440"/>
           <a:lstStyle/>
           <a:p>
             <a:pPr>
@@ -12710,7 +12021,7 @@
 </file>
 
 <file path=ppt/slides/slide7.xml><?xml version="1.0" encoding="utf-8"?>
-<p:sld xmlns:a="http://schemas.openxmlformats.org/drawingml/2006/main" xmlns:r="http://schemas.openxmlformats.org/officeDocument/2006/relationships" xmlns:p="http://schemas.openxmlformats.org/presentationml/2006/main">
+<p:sld xmlns:a="http://schemas.openxmlformats.org/drawingml/2006/main" xmlns:p="http://schemas.openxmlformats.org/presentationml/2006/main" xmlns:r="http://schemas.openxmlformats.org/officeDocument/2006/relationships">
   <p:cSld>
     <p:spTree>
       <p:nvGrpSpPr>
@@ -12718,14 +12029,7 @@
         <p:cNvGrpSpPr/>
         <p:nvPr/>
       </p:nvGrpSpPr>
-      <p:grpSpPr>
-        <a:xfrm>
-          <a:off x="0" y="0"/>
-          <a:ext cx="0" cy="0"/>
-          <a:chOff x="0" y="0"/>
-          <a:chExt cx="0" cy="0"/>
-        </a:xfrm>
-      </p:grpSpPr>
+      <p:grpSpPr/>
       <p:sp>
         <p:nvSpPr>
           <p:cNvPr id="2" name="Title 1"/>
@@ -12765,7 +12069,7 @@
           </a:xfrm>
         </p:spPr>
         <p:txBody>
-          <a:bodyPr wrap="square" lIns="109728" tIns="91440" rIns="109728" bIns="91440"/>
+          <a:bodyPr wrap="square" lIns="109728" rIns="109728" tIns="91440" bIns="91440"/>
           <a:lstStyle/>
           <a:p>
             <a:pPr>
@@ -13020,7 +12324,7 @@
 </file>
 
 <file path=ppt/slides/slide8.xml><?xml version="1.0" encoding="utf-8"?>
-<p:sld xmlns:a="http://schemas.openxmlformats.org/drawingml/2006/main" xmlns:r="http://schemas.openxmlformats.org/officeDocument/2006/relationships" xmlns:p="http://schemas.openxmlformats.org/presentationml/2006/main">
+<p:sld xmlns:a="http://schemas.openxmlformats.org/drawingml/2006/main" xmlns:p="http://schemas.openxmlformats.org/presentationml/2006/main" xmlns:r="http://schemas.openxmlformats.org/officeDocument/2006/relationships">
   <p:cSld>
     <p:spTree>
       <p:nvGrpSpPr>
@@ -13028,14 +12332,7 @@
         <p:cNvGrpSpPr/>
         <p:nvPr/>
       </p:nvGrpSpPr>
-      <p:grpSpPr>
-        <a:xfrm>
-          <a:off x="0" y="0"/>
-          <a:ext cx="0" cy="0"/>
-          <a:chOff x="0" y="0"/>
-          <a:chExt cx="0" cy="0"/>
-        </a:xfrm>
-      </p:grpSpPr>
+      <p:grpSpPr/>
       <p:sp>
         <p:nvSpPr>
           <p:cNvPr id="2" name="Title 1"/>
@@ -13075,7 +12372,7 @@
           </a:xfrm>
         </p:spPr>
         <p:txBody>
-          <a:bodyPr wrap="square" lIns="109728" tIns="91440" rIns="109728" bIns="91440"/>
+          <a:bodyPr wrap="square" lIns="109728" rIns="109728" tIns="91440" bIns="91440"/>
           <a:lstStyle/>
           <a:p>
             <a:pPr>
@@ -13210,7 +12507,7 @@
 </file>
 
 <file path=ppt/slides/slide9.xml><?xml version="1.0" encoding="utf-8"?>
-<p:sld xmlns:a="http://schemas.openxmlformats.org/drawingml/2006/main" xmlns:r="http://schemas.openxmlformats.org/officeDocument/2006/relationships" xmlns:p="http://schemas.openxmlformats.org/presentationml/2006/main">
+<p:sld xmlns:a="http://schemas.openxmlformats.org/drawingml/2006/main" xmlns:p="http://schemas.openxmlformats.org/presentationml/2006/main" xmlns:r="http://schemas.openxmlformats.org/officeDocument/2006/relationships">
   <p:cSld>
     <p:spTree>
       <p:nvGrpSpPr>
@@ -13218,14 +12515,7 @@
         <p:cNvGrpSpPr/>
         <p:nvPr/>
       </p:nvGrpSpPr>
-      <p:grpSpPr>
-        <a:xfrm>
-          <a:off x="0" y="0"/>
-          <a:ext cx="0" cy="0"/>
-          <a:chOff x="0" y="0"/>
-          <a:chExt cx="0" cy="0"/>
-        </a:xfrm>
-      </p:grpSpPr>
+      <p:grpSpPr/>
       <p:sp>
         <p:nvSpPr>
           <p:cNvPr id="2" name="Title 1"/>
@@ -13265,7 +12555,7 @@
           </a:xfrm>
         </p:spPr>
         <p:txBody>
-          <a:bodyPr wrap="square" lIns="109728" tIns="91440" rIns="109728" bIns="91440"/>
+          <a:bodyPr wrap="square" lIns="109728" rIns="109728" tIns="91440" bIns="91440"/>
           <a:lstStyle/>
           <a:p>
             <a:pPr>

</xml_diff>